<commit_message>
Summary deck: represent 2021 baseline output honestly as high-probability regions, not a spin list
The window-bank probability curve on NV1 shows a continuous plateau
(p 0.86-1.00) over A in [-6,+12]; peak picking artificially quantized it
into {+2,+12}, dropping +8 (p=0.95). The core pipeline localizes regions,
not individual spins - now stated as such.

Co-Authored-By: Claude Fable 5 <noreply@anthropic.com>
</commit_message>
<xml_diff>
--- a/results/NV_C13_summary_3slides.pptx
+++ b/results/NV_C13_summary_3slides.pptx
@@ -3136,7 +3136,7 @@
               </a:defRPr>
             </a:pPr>
             <a:r>
-              <a:t>▶ 수동 4개 → 2021 방법 8개(위치만) → 제안 방법 14개(결합강도+오차막대) — 앵커 전부 회수 + 신규 10개</a:t>
+              <a:t>▶ 수동 4개 → 2021 방법은 고확률 영역까지만(개별 분해 불가) → 제안 방법 14개(결합강도+오차막대) — 앵커 전부 회수</a:t>
             </a:r>
           </a:p>
         </p:txBody>
@@ -3316,7 +3316,7 @@
                         <a:defRPr sz="1000" b="1"/>
                       </a:pPr>
                       <a:r>
-                        <a:t>8개 — A 위치만</a:t>
+                        <a:t>스핀 목록이 아닌 '영역'만 출력</a:t>
                       </a:r>
                     </a:p>
                     <a:p>
@@ -3324,7 +3324,7 @@
                         <a:defRPr sz="1000"/>
                       </a:pPr>
                       <a:r>
-                        <a:t>−34, −20, −6, +2,</a:t>
+                        <a:t>고확률 영역: A∈[−6,+12]</a:t>
                       </a:r>
                     </a:p>
                     <a:p>
@@ -3332,7 +3332,7 @@
                         <a:defRPr sz="1000"/>
                       </a:pPr>
                       <a:r>
-                        <a:t>+12, +22, +42, +46</a:t>
+                        <a:t>(p 0.86~1.00 연속 고원),</a:t>
                       </a:r>
                     </a:p>
                     <a:p>
@@ -3340,7 +3340,23 @@
                         <a:defRPr sz="1000"/>
                       </a:pPr>
                       <a:r>
-                        <a:t>(B는 별도 회귀 필요)</a:t>
+                        <a:t>A∈[+40,+46] + 피크 −34, −20, +22</a:t>
+                      </a:r>
+                    </a:p>
+                    <a:p>
+                      <a:pPr>
+                        <a:defRPr sz="1000"/>
+                      </a:pPr>
+                      <a:r>
+                        <a:t>※ 개별 스핀 분해·B값은</a:t>
+                      </a:r>
+                    </a:p>
+                    <a:p>
+                      <a:pPr>
+                        <a:defRPr sz="1000"/>
+                      </a:pPr>
+                      <a:r>
+                        <a:t>별도 회귀 단계 필요(미재현)</a:t>
                       </a:r>
                     </a:p>
                   </a:txBody>
@@ -3584,7 +3600,7 @@
                         <a:defRPr sz="1000" b="1"/>
                       </a:pPr>
                       <a:r>
-                        <a:t>문턱값 피크</a:t>
+                        <a:t>윈도우 확률 고원 —</a:t>
                       </a:r>
                     </a:p>
                     <a:p>
@@ -3592,7 +3608,23 @@
                         <a:defRPr sz="1000"/>
                       </a:pPr>
                       <a:r>
-                        <a:t>오탐 포함 (P 0.55~0.78)</a:t>
+                        <a:t>고원 내 개별 스핀 분해 불가</a:t>
+                      </a:r>
+                    </a:p>
+                    <a:p>
+                      <a:pPr>
+                        <a:defRPr sz="1000"/>
+                      </a:pPr>
+                      <a:r>
+                        <a:t>(예: 최강 스핀 +8이 p=0.95인데도</a:t>
+                      </a:r>
+                    </a:p>
+                    <a:p>
+                      <a:pPr>
+                        <a:defRPr sz="1000"/>
+                      </a:pPr>
+                      <a:r>
+                        <a:t>피크 검출에서 누락됨)</a:t>
                       </a:r>
                     </a:p>
                   </a:txBody>

</xml_diff>

<commit_message>
Summary deck: add cross-method consensus tier slide (4th) + method_overlap.md
Co-Authored-By: Claude Fable 5 <noreply@anthropic.com>
</commit_message>
<xml_diff>
--- a/results/NV_C13_summary_3slides.pptx
+++ b/results/NV_C13_summary_3slides.pptx
@@ -8,6 +8,7 @@
     <p:sldId id="256" r:id="rId7"/>
     <p:sldId id="257" r:id="rId8"/>
     <p:sldId id="258" r:id="rId9"/>
+    <p:sldId id="259" r:id="rId10"/>
   </p:sldIdLst>
   <p:sldSz cx="12191695" cy="6858000" type="screen4x3"/>
   <p:notesSz cx="6858000" cy="9144000"/>
@@ -3965,6 +3966,874 @@
             </a:pPr>
             <a:r>
               <a:t>• 왼쪽 NV1: 위→아래 N=8/16/20 — 같은 14개 스핀 목록 하나가 세 데이터를 모두 설명    • 오른쪽 NV2: 강결합 프린지 구조까지 추적 (단일 채널 한계로 1개 스핀 보류)</a:t>
+            </a:r>
+          </a:p>
+        </p:txBody>
+      </p:sp>
+    </p:spTree>
+  </p:cSld>
+  <p:clrMapOvr>
+    <a:masterClrMapping/>
+  </p:clrMapOvr>
+</p:sld>
+</file>
+
+<file path=ppt/slides/slide4.xml><?xml version="1.0" encoding="utf-8"?>
+<p:sld xmlns:a="http://schemas.openxmlformats.org/drawingml/2006/main" xmlns:p="http://schemas.openxmlformats.org/presentationml/2006/main" xmlns:r="http://schemas.openxmlformats.org/officeDocument/2006/relationships">
+  <p:cSld>
+    <p:spTree>
+      <p:nvGrpSpPr>
+        <p:cNvPr id="1" name=""/>
+        <p:cNvGrpSpPr/>
+        <p:nvPr/>
+      </p:nvGrpSpPr>
+      <p:grpSpPr/>
+      <p:sp>
+        <p:nvSpPr>
+          <p:cNvPr id="2" name="TextBox 1"/>
+          <p:cNvSpPr txBox="1"/>
+          <p:nvPr/>
+        </p:nvSpPr>
+        <p:spPr>
+          <a:xfrm>
+            <a:off x="365760" y="109728"/>
+            <a:ext cx="11430000" cy="914400"/>
+          </a:xfrm>
+          <a:prstGeom prst="rect">
+            <a:avLst/>
+          </a:prstGeom>
+          <a:noFill/>
+        </p:spPr>
+        <p:txBody>
+          <a:bodyPr wrap="none">
+            <a:spAutoFit/>
+          </a:bodyPr>
+          <a:lstStyle/>
+          <a:p>
+            <a:pPr>
+              <a:defRPr sz="2600" b="1"/>
+            </a:pPr>
+            <a:r>
+              <a:t>요약 ④: 방법 간 겹쳐서 찾은 스핀 — 합의 등급</a:t>
+            </a:r>
+          </a:p>
+          <a:p>
+            <a:pPr>
+              <a:defRPr sz="1200"/>
+            </a:pPr>
+            <a:r>
+              <a:t>허용오차 ±4 kHz · 계열 = 수동 / 2021영역 / CNN뱅크 / DE / SpinDETR / PF / 하이브리드</a:t>
+            </a:r>
+          </a:p>
+          <a:p>
+            <a:pPr>
+              <a:defRPr sz="1400" b="1">
+                <a:solidFill>
+                  <a:srgbClr val="B45000"/>
+                </a:solidFill>
+              </a:defRPr>
+            </a:pPr>
+            <a:r>
+              <a:t>▶ 핵심 스핀은 원리가 다른 모든 방법과 사람 눈까지 일치 — 합의가 낮아지는 순서는 탐색범위를 벗어나는 순서와 일치</a:t>
+            </a:r>
+          </a:p>
+        </p:txBody>
+      </p:sp>
+      <p:sp>
+        <p:nvSpPr>
+          <p:cNvPr id="3" name="TextBox 2"/>
+          <p:cNvSpPr txBox="1"/>
+          <p:nvPr/>
+        </p:nvSpPr>
+        <p:spPr>
+          <a:xfrm>
+            <a:off x="274320" y="1371600"/>
+            <a:ext cx="5989320" cy="320040"/>
+          </a:xfrm>
+          <a:prstGeom prst="rect">
+            <a:avLst/>
+          </a:prstGeom>
+          <a:noFill/>
+        </p:spPr>
+        <p:txBody>
+          <a:bodyPr wrap="none">
+            <a:spAutoFit/>
+          </a:bodyPr>
+          <a:lstStyle/>
+          <a:p>
+            <a:pPr>
+              <a:defRPr sz="1400" b="1"/>
+            </a:pPr>
+            <a:r>
+              <a:t>NV1 (14스핀 + 후보 1)</a:t>
+            </a:r>
+          </a:p>
+        </p:txBody>
+      </p:sp>
+      <p:graphicFrame>
+        <p:nvGraphicFramePr>
+          <p:cNvPr id="4" name="Table 3"/>
+          <p:cNvGraphicFramePr>
+            <a:graphicFrameLocks noGrp="1"/>
+          </p:cNvGraphicFramePr>
+          <p:nvPr/>
+        </p:nvGraphicFramePr>
+        <p:xfrm>
+          <a:off x="274320" y="1737360"/>
+          <a:ext cx="5989320" cy="4480560"/>
+        </p:xfrm>
+        <a:graphic>
+          <a:graphicData uri="http://schemas.openxmlformats.org/drawingml/2006/table">
+            <a:tbl>
+              <a:tblPr firstRow="1" bandRow="1">
+                <a:tableStyleId>{5C22544A-7EE6-4342-B048-85BDC9FD1C3A}</a:tableStyleId>
+              </a:tblPr>
+              <a:tblGrid>
+                <a:gridCol w="1234440"/>
+                <a:gridCol w="2468880"/>
+                <a:gridCol w="2286000"/>
+              </a:tblGrid>
+              <a:tr h="746760">
+                <a:tc>
+                  <a:txBody>
+                    <a:bodyPr/>
+                    <a:lstStyle/>
+                    <a:p>
+                      <a:pPr>
+                        <a:defRPr sz="1000" b="1"/>
+                      </a:pPr>
+                      <a:r>
+                        <a:t>등급</a:t>
+                      </a:r>
+                    </a:p>
+                  </a:txBody>
+                  <a:tcPr/>
+                </a:tc>
+                <a:tc>
+                  <a:txBody>
+                    <a:bodyPr/>
+                    <a:lstStyle/>
+                    <a:p>
+                      <a:pPr>
+                        <a:defRPr sz="1000" b="1"/>
+                      </a:pPr>
+                      <a:r>
+                        <a:t>스핀 (A∥, A⊥)</a:t>
+                      </a:r>
+                    </a:p>
+                  </a:txBody>
+                  <a:tcPr/>
+                </a:tc>
+                <a:tc>
+                  <a:txBody>
+                    <a:bodyPr/>
+                    <a:lstStyle/>
+                    <a:p>
+                      <a:pPr>
+                        <a:defRPr sz="1000" b="1"/>
+                      </a:pPr>
+                      <a:r>
+                        <a:t>겹친 계열</a:t>
+                      </a:r>
+                    </a:p>
+                  </a:txBody>
+                  <a:tcPr/>
+                </a:tc>
+              </a:tr>
+              <a:tr h="746760">
+                <a:tc>
+                  <a:txBody>
+                    <a:bodyPr/>
+                    <a:lstStyle/>
+                    <a:p>
+                      <a:pPr>
+                        <a:defRPr sz="850" b="1"/>
+                      </a:pPr>
+                      <a:r>
+                        <a:t>🥇 전원 7계열</a:t>
+                      </a:r>
+                    </a:p>
+                    <a:p>
+                      <a:pPr>
+                        <a:defRPr sz="850" b="1"/>
+                      </a:pPr>
+                      <a:r>
+                        <a:t>(+앵커)</a:t>
+                      </a:r>
+                    </a:p>
+                  </a:txBody>
+                  <a:tcPr/>
+                </a:tc>
+                <a:tc>
+                  <a:txBody>
+                    <a:bodyPr/>
+                    <a:lstStyle/>
+                    <a:p>
+                      <a:pPr>
+                        <a:defRPr sz="850"/>
+                      </a:pPr>
+                      <a:r>
+                        <a:t>(−5.1, 22)  (+8.4, 28)  (+39.0, 28)</a:t>
+                      </a:r>
+                    </a:p>
+                  </a:txBody>
+                  <a:tcPr/>
+                </a:tc>
+                <a:tc>
+                  <a:txBody>
+                    <a:bodyPr/>
+                    <a:lstStyle/>
+                    <a:p>
+                      <a:pPr>
+                        <a:defRPr sz="850"/>
+                      </a:pPr>
+                      <a:r>
+                        <a:t>수동·2021영역·CNN·DE·</a:t>
+                      </a:r>
+                    </a:p>
+                    <a:p>
+                      <a:pPr>
+                        <a:defRPr sz="850"/>
+                      </a:pPr>
+                      <a:r>
+                        <a:t>SpinDETR·PF·하이브리드 전부</a:t>
+                      </a:r>
+                    </a:p>
+                  </a:txBody>
+                  <a:tcPr/>
+                </a:tc>
+              </a:tr>
+              <a:tr h="746760">
+                <a:tc>
+                  <a:txBody>
+                    <a:bodyPr/>
+                    <a:lstStyle/>
+                    <a:p>
+                      <a:pPr>
+                        <a:defRPr sz="850" b="1"/>
+                      </a:pPr>
+                      <a:r>
+                        <a:t>🥈 5–6계열</a:t>
+                      </a:r>
+                    </a:p>
+                  </a:txBody>
+                  <a:tcPr/>
+                </a:tc>
+                <a:tc>
+                  <a:txBody>
+                    <a:bodyPr/>
+                    <a:lstStyle/>
+                    <a:p>
+                      <a:pPr>
+                        <a:defRPr sz="850"/>
+                      </a:pPr>
+                      <a:r>
+                        <a:t>(−18.8, 16)  (+0.6, 17)</a:t>
+                      </a:r>
+                    </a:p>
+                    <a:p>
+                      <a:pPr>
+                        <a:defRPr sz="850"/>
+                      </a:pPr>
+                      <a:r>
+                        <a:t>(+4.0, 26)  (+14.2, 22)</a:t>
+                      </a:r>
+                    </a:p>
+                  </a:txBody>
+                  <a:tcPr/>
+                </a:tc>
+                <a:tc>
+                  <a:txBody>
+                    <a:bodyPr/>
+                    <a:lstStyle/>
+                    <a:p>
+                      <a:pPr>
+                        <a:defRPr sz="850"/>
+                      </a:pPr>
+                      <a:r>
+                        <a:t>중앙 고원 합의</a:t>
+                      </a:r>
+                    </a:p>
+                    <a:p>
+                      <a:pPr>
+                        <a:defRPr sz="850"/>
+                      </a:pPr>
+                      <a:r>
+                        <a:t>(DE 또는 SpinDETR 일부 누락)</a:t>
+                      </a:r>
+                    </a:p>
+                  </a:txBody>
+                  <a:tcPr/>
+                </a:tc>
+              </a:tr>
+              <a:tr h="746760">
+                <a:tc>
+                  <a:txBody>
+                    <a:bodyPr/>
+                    <a:lstStyle/>
+                    <a:p>
+                      <a:pPr>
+                        <a:defRPr sz="850" b="1"/>
+                      </a:pPr>
+                      <a:r>
+                        <a:t>🥉 3–4계열</a:t>
+                      </a:r>
+                    </a:p>
+                  </a:txBody>
+                  <a:tcPr/>
+                </a:tc>
+                <a:tc>
+                  <a:txBody>
+                    <a:bodyPr/>
+                    <a:lstStyle/>
+                    <a:p>
+                      <a:pPr>
+                        <a:defRPr sz="850"/>
+                      </a:pPr>
+                      <a:r>
+                        <a:t>(−87.9, 18)*  (+24.3, 20)</a:t>
+                      </a:r>
+                    </a:p>
+                    <a:p>
+                      <a:pPr>
+                        <a:defRPr sz="850"/>
+                      </a:pPr>
+                      <a:r>
+                        <a:t>(+48.0, 25)  (+65.6, 28)  (+91.9, 33)</a:t>
+                      </a:r>
+                    </a:p>
+                  </a:txBody>
+                  <a:tcPr/>
+                </a:tc>
+                <a:tc>
+                  <a:txBody>
+                    <a:bodyPr/>
+                    <a:lstStyle/>
+                    <a:p>
+                      <a:pPr>
+                        <a:defRPr sz="850"/>
+                      </a:pPr>
+                      <a:r>
+                        <a:t>*−87.9는 ±60 밖을 보는</a:t>
+                      </a:r>
+                    </a:p>
+                    <a:p>
+                      <a:pPr>
+                        <a:defRPr sz="850"/>
+                      </a:pPr>
+                      <a:r>
+                        <a:t>방법 전원 일치 + 앵커 −88</a:t>
+                      </a:r>
+                    </a:p>
+                  </a:txBody>
+                  <a:tcPr/>
+                </a:tc>
+              </a:tr>
+              <a:tr h="746760">
+                <a:tc>
+                  <a:txBody>
+                    <a:bodyPr/>
+                    <a:lstStyle/>
+                    <a:p>
+                      <a:pPr>
+                        <a:defRPr sz="850" b="1"/>
+                      </a:pPr>
+                      <a:r>
+                        <a:t>⚠ ≤2계열</a:t>
+                      </a:r>
+                    </a:p>
+                  </a:txBody>
+                  <a:tcPr/>
+                </a:tc>
+                <a:tc>
+                  <a:txBody>
+                    <a:bodyPr/>
+                    <a:lstStyle/>
+                    <a:p>
+                      <a:pPr>
+                        <a:defRPr sz="850"/>
+                      </a:pPr>
+                      <a:r>
+                        <a:t>(−11.5, 14)  (+114.4, 24)</a:t>
+                      </a:r>
+                    </a:p>
+                  </a:txBody>
+                  <a:tcPr/>
+                </a:tc>
+                <a:tc>
+                  <a:txBody>
+                    <a:bodyPr/>
+                    <a:lstStyle/>
+                    <a:p>
+                      <a:pPr>
+                        <a:defRPr sz="850"/>
+                      </a:pPr>
+                      <a:r>
+                        <a:t>하이브리드 계열 / PF 광역만</a:t>
+                      </a:r>
+                    </a:p>
+                  </a:txBody>
+                  <a:tcPr/>
+                </a:tc>
+              </a:tr>
+              <a:tr h="746760">
+                <a:tc>
+                  <a:txBody>
+                    <a:bodyPr/>
+                    <a:lstStyle/>
+                    <a:p>
+                      <a:pPr>
+                        <a:defRPr sz="850" b="1"/>
+                      </a:pPr>
+                      <a:r>
+                        <a:t>📌 목록 외 후보</a:t>
+                      </a:r>
+                    </a:p>
+                  </a:txBody>
+                  <a:tcPr/>
+                </a:tc>
+                <a:tc>
+                  <a:txBody>
+                    <a:bodyPr/>
+                    <a:lstStyle/>
+                    <a:p>
+                      <a:pPr>
+                        <a:defRPr sz="850"/>
+                      </a:pPr>
+                      <a:r>
+                        <a:t>A ≈ −30~−34</a:t>
+                      </a:r>
+                    </a:p>
+                  </a:txBody>
+                  <a:tcPr/>
+                </a:tc>
+                <a:tc>
+                  <a:txBody>
+                    <a:bodyPr/>
+                    <a:lstStyle/>
+                    <a:p>
+                      <a:pPr>
+                        <a:defRPr sz="850"/>
+                      </a:pPr>
+                      <a:r>
+                        <a:t>2021(−34)·CNN(−30)·</a:t>
+                      </a:r>
+                    </a:p>
+                    <a:p>
+                      <a:pPr>
+                        <a:defRPr sz="850"/>
+                      </a:pPr>
+                      <a:r>
+                        <a:t>SpinDETR(−34.4) 3계열 겹침</a:t>
+                      </a:r>
+                    </a:p>
+                  </a:txBody>
+                  <a:tcPr/>
+                </a:tc>
+              </a:tr>
+            </a:tbl>
+          </a:graphicData>
+        </a:graphic>
+      </p:graphicFrame>
+      <p:sp>
+        <p:nvSpPr>
+          <p:cNvPr id="5" name="TextBox 4"/>
+          <p:cNvSpPr txBox="1"/>
+          <p:nvPr/>
+        </p:nvSpPr>
+        <p:spPr>
+          <a:xfrm>
+            <a:off x="6446520" y="1371600"/>
+            <a:ext cx="5486400" cy="320040"/>
+          </a:xfrm>
+          <a:prstGeom prst="rect">
+            <a:avLst/>
+          </a:prstGeom>
+          <a:noFill/>
+        </p:spPr>
+        <p:txBody>
+          <a:bodyPr wrap="none">
+            <a:spAutoFit/>
+          </a:bodyPr>
+          <a:lstStyle/>
+          <a:p>
+            <a:pPr>
+              <a:defRPr sz="1400" b="1"/>
+            </a:pPr>
+            <a:r>
+              <a:t>NV2 (10스핀)</a:t>
+            </a:r>
+          </a:p>
+        </p:txBody>
+      </p:sp>
+      <p:graphicFrame>
+        <p:nvGraphicFramePr>
+          <p:cNvPr id="6" name="Table 5"/>
+          <p:cNvGraphicFramePr>
+            <a:graphicFrameLocks noGrp="1"/>
+          </p:cNvGraphicFramePr>
+          <p:nvPr/>
+        </p:nvGraphicFramePr>
+        <p:xfrm>
+          <a:off x="6446520" y="1737360"/>
+          <a:ext cx="5486400" cy="4480560"/>
+        </p:xfrm>
+        <a:graphic>
+          <a:graphicData uri="http://schemas.openxmlformats.org/drawingml/2006/table">
+            <a:tbl>
+              <a:tblPr firstRow="1" bandRow="1">
+                <a:tableStyleId>{5C22544A-7EE6-4342-B048-85BDC9FD1C3A}</a:tableStyleId>
+              </a:tblPr>
+              <a:tblGrid>
+                <a:gridCol w="1234440"/>
+                <a:gridCol w="2148840"/>
+                <a:gridCol w="2103120"/>
+              </a:tblGrid>
+              <a:tr h="746760">
+                <a:tc>
+                  <a:txBody>
+                    <a:bodyPr/>
+                    <a:lstStyle/>
+                    <a:p>
+                      <a:pPr>
+                        <a:defRPr sz="1000" b="1"/>
+                      </a:pPr>
+                      <a:r>
+                        <a:t>등급</a:t>
+                      </a:r>
+                    </a:p>
+                  </a:txBody>
+                  <a:tcPr/>
+                </a:tc>
+                <a:tc>
+                  <a:txBody>
+                    <a:bodyPr/>
+                    <a:lstStyle/>
+                    <a:p>
+                      <a:pPr>
+                        <a:defRPr sz="1000" b="1"/>
+                      </a:pPr>
+                      <a:r>
+                        <a:t>스핀 (A∥, A⊥)</a:t>
+                      </a:r>
+                    </a:p>
+                  </a:txBody>
+                  <a:tcPr/>
+                </a:tc>
+                <a:tc>
+                  <a:txBody>
+                    <a:bodyPr/>
+                    <a:lstStyle/>
+                    <a:p>
+                      <a:pPr>
+                        <a:defRPr sz="1000" b="1"/>
+                      </a:pPr>
+                      <a:r>
+                        <a:t>겹친 계열</a:t>
+                      </a:r>
+                    </a:p>
+                  </a:txBody>
+                  <a:tcPr/>
+                </a:tc>
+              </a:tr>
+              <a:tr h="746760">
+                <a:tc>
+                  <a:txBody>
+                    <a:bodyPr/>
+                    <a:lstStyle/>
+                    <a:p>
+                      <a:pPr>
+                        <a:defRPr sz="850" b="1"/>
+                      </a:pPr>
+                      <a:r>
+                        <a:t>🥇 전원+앵커</a:t>
+                      </a:r>
+                    </a:p>
+                  </a:txBody>
+                  <a:tcPr/>
+                </a:tc>
+                <a:tc>
+                  <a:txBody>
+                    <a:bodyPr/>
+                    <a:lstStyle/>
+                    <a:p>
+                      <a:pPr>
+                        <a:defRPr sz="850"/>
+                      </a:pPr>
+                      <a:r>
+                        <a:t>(+346.9, 261)  (−38.9, 67)</a:t>
+                      </a:r>
+                    </a:p>
+                  </a:txBody>
+                  <a:tcPr/>
+                </a:tc>
+                <a:tc>
+                  <a:txBody>
+                    <a:bodyPr/>
+                    <a:lstStyle/>
+                    <a:p>
+                      <a:pPr>
+                        <a:defRPr sz="850"/>
+                      </a:pPr>
+                      <a:r>
+                        <a:t>PF±400/±600·DE·하이브리드</a:t>
+                      </a:r>
+                    </a:p>
+                    <a:p>
+                      <a:pPr>
+                        <a:defRPr sz="850"/>
+                      </a:pPr>
+                      <a:r>
+                        <a:t>전 버전 + 앵커</a:t>
+                      </a:r>
+                    </a:p>
+                  </a:txBody>
+                  <a:tcPr/>
+                </a:tc>
+              </a:tr>
+              <a:tr h="746760">
+                <a:tc>
+                  <a:txBody>
+                    <a:bodyPr/>
+                    <a:lstStyle/>
+                    <a:p>
+                      <a:pPr>
+                        <a:defRPr sz="850" b="1"/>
+                      </a:pPr>
+                      <a:r>
+                        <a:t>🥈 4계열</a:t>
+                      </a:r>
+                    </a:p>
+                  </a:txBody>
+                  <a:tcPr/>
+                </a:tc>
+                <a:tc>
+                  <a:txBody>
+                    <a:bodyPr/>
+                    <a:lstStyle/>
+                    <a:p>
+                      <a:pPr>
+                        <a:defRPr sz="850"/>
+                      </a:pPr>
+                      <a:r>
+                        <a:t>(−58.9, 182)  (−12.6, 42)</a:t>
+                      </a:r>
+                    </a:p>
+                    <a:p>
+                      <a:pPr>
+                        <a:defRPr sz="850"/>
+                      </a:pPr>
+                      <a:r>
+                        <a:t>(+51.7, 91)</a:t>
+                      </a:r>
+                    </a:p>
+                  </a:txBody>
+                  <a:tcPr/>
+                </a:tc>
+                <a:tc>
+                  <a:txBody>
+                    <a:bodyPr/>
+                    <a:lstStyle/>
+                    <a:p>
+                      <a:pPr>
+                        <a:defRPr sz="850"/>
+                      </a:pPr>
+                      <a:r>
+                        <a:t>PF·DE·v1·refined</a:t>
+                      </a:r>
+                    </a:p>
+                  </a:txBody>
+                  <a:tcPr/>
+                </a:tc>
+              </a:tr>
+              <a:tr h="746760">
+                <a:tc>
+                  <a:txBody>
+                    <a:bodyPr/>
+                    <a:lstStyle/>
+                    <a:p>
+                      <a:pPr>
+                        <a:defRPr sz="850" b="1"/>
+                      </a:pPr>
+                      <a:r>
+                        <a:t>🥉 3계열</a:t>
+                      </a:r>
+                    </a:p>
+                  </a:txBody>
+                  <a:tcPr/>
+                </a:tc>
+                <a:tc>
+                  <a:txBody>
+                    <a:bodyPr/>
+                    <a:lstStyle/>
+                    <a:p>
+                      <a:pPr>
+                        <a:defRPr sz="850"/>
+                      </a:pPr>
+                      <a:r>
+                        <a:t>(+55.9, 55)</a:t>
+                      </a:r>
+                    </a:p>
+                  </a:txBody>
+                  <a:tcPr/>
+                </a:tc>
+                <a:tc>
+                  <a:txBody>
+                    <a:bodyPr/>
+                    <a:lstStyle/>
+                    <a:p>
+                      <a:pPr>
+                        <a:defRPr sz="850"/>
+                      </a:pPr>
+                      <a:r>
+                        <a:t>PF·v1·앙상블</a:t>
+                      </a:r>
+                    </a:p>
+                  </a:txBody>
+                  <a:tcPr/>
+                </a:tc>
+              </a:tr>
+              <a:tr h="746760">
+                <a:tc>
+                  <a:txBody>
+                    <a:bodyPr/>
+                    <a:lstStyle/>
+                    <a:p>
+                      <a:pPr>
+                        <a:defRPr sz="850" b="1"/>
+                      </a:pPr>
+                      <a:r>
+                        <a:t>2계열+앵커</a:t>
+                      </a:r>
+                    </a:p>
+                  </a:txBody>
+                  <a:tcPr/>
+                </a:tc>
+                <a:tc>
+                  <a:txBody>
+                    <a:bodyPr/>
+                    <a:lstStyle/>
+                    <a:p>
+                      <a:pPr>
+                        <a:defRPr sz="850"/>
+                      </a:pPr>
+                      <a:r>
+                        <a:t>(−151.2, 95)</a:t>
+                      </a:r>
+                    </a:p>
+                  </a:txBody>
+                  <a:tcPr/>
+                </a:tc>
+                <a:tc>
+                  <a:txBody>
+                    <a:bodyPr/>
+                    <a:lstStyle/>
+                    <a:p>
+                      <a:pPr>
+                        <a:defRPr sz="850"/>
+                      </a:pPr>
+                      <a:r>
+                        <a:t>DE·앙상블 + 앵커 +150</a:t>
+                      </a:r>
+                    </a:p>
+                    <a:p>
+                      <a:pPr>
+                        <a:defRPr sz="850"/>
+                      </a:pPr>
+                      <a:r>
+                        <a:t>(PF만 놓침)</a:t>
+                      </a:r>
+                    </a:p>
+                  </a:txBody>
+                  <a:tcPr/>
+                </a:tc>
+              </a:tr>
+              <a:tr h="746760">
+                <a:tc>
+                  <a:txBody>
+                    <a:bodyPr/>
+                    <a:lstStyle/>
+                    <a:p>
+                      <a:pPr>
+                        <a:defRPr sz="850" b="1"/>
+                      </a:pPr>
+                      <a:r>
+                        <a:t>⚠ ≤2계열</a:t>
+                      </a:r>
+                    </a:p>
+                  </a:txBody>
+                  <a:tcPr/>
+                </a:tc>
+                <a:tc>
+                  <a:txBody>
+                    <a:bodyPr/>
+                    <a:lstStyle/>
+                    <a:p>
+                      <a:pPr>
+                        <a:defRPr sz="850"/>
+                      </a:pPr>
+                      <a:r>
+                        <a:t>(−45.9, 50)  (−2.7, 37)</a:t>
+                      </a:r>
+                    </a:p>
+                    <a:p>
+                      <a:pPr>
+                        <a:defRPr sz="850"/>
+                      </a:pPr>
+                      <a:r>
+                        <a:t>(+430.7, 58) 보류</a:t>
+                      </a:r>
+                    </a:p>
+                  </a:txBody>
+                  <a:tcPr/>
+                </a:tc>
+                <a:tc>
+                  <a:txBody>
+                    <a:bodyPr/>
+                    <a:lstStyle/>
+                    <a:p>
+                      <a:pPr>
+                        <a:defRPr sz="850"/>
+                      </a:pPr>
+                      <a:r>
+                        <a:t>하이브리드 계열만</a:t>
+                      </a:r>
+                    </a:p>
+                  </a:txBody>
+                  <a:tcPr/>
+                </a:tc>
+              </a:tr>
+            </a:tbl>
+          </a:graphicData>
+        </a:graphic>
+      </p:graphicFrame>
+      <p:sp>
+        <p:nvSpPr>
+          <p:cNvPr id="7" name="TextBox 6"/>
+          <p:cNvSpPr txBox="1"/>
+          <p:nvPr/>
+        </p:nvSpPr>
+        <p:spPr>
+          <a:xfrm>
+            <a:off x="365760" y="6355080"/>
+            <a:ext cx="11430000" cy="411480"/>
+          </a:xfrm>
+          <a:prstGeom prst="rect">
+            <a:avLst/>
+          </a:prstGeom>
+          <a:noFill/>
+        </p:spPr>
+        <p:txBody>
+          <a:bodyPr wrap="none">
+            <a:spAutoFit/>
+          </a:bodyPr>
+          <a:lstStyle/>
+          <a:p>
+            <a:pPr>
+              <a:defRPr sz="1150"/>
+            </a:pPr>
+            <a:r>
+              <a:t>• 읽는 법: 등급이 낮은 스핀은 '의심스러운' 것이 아니라 대부분 |A|가 커서 좁은-범위 방법들의 시야 밖 — 불일치가 아니라 각 방법의 탐색 범위 문제임이 구조적으로 설명됨</a:t>
             </a:r>
           </a:p>
         </p:txBody>

</xml_diff>

<commit_message>
Summary deck: final definitive spin-list slide with (A_par +- CI, A_perp) cells and concise notes
Co-Authored-By: Claude Fable 5 <noreply@anthropic.com>
</commit_message>
<xml_diff>
--- a/results/NV_C13_summary_3slides.pptx
+++ b/results/NV_C13_summary_3slides.pptx
@@ -9,6 +9,7 @@
     <p:sldId id="257" r:id="rId8"/>
     <p:sldId id="258" r:id="rId9"/>
     <p:sldId id="259" r:id="rId10"/>
+    <p:sldId id="260" r:id="rId11"/>
   </p:sldIdLst>
   <p:sldSz cx="12191695" cy="6858000" type="screen4x3"/>
   <p:notesSz cx="6858000" cy="9144000"/>
@@ -4834,6 +4835,778 @@
             </a:pPr>
             <a:r>
               <a:t>• 읽는 법: 등급이 낮은 스핀은 '의심스러운' 것이 아니라 대부분 |A|가 커서 좁은-범위 방법들의 시야 밖 — 불일치가 아니라 각 방법의 탐색 범위 문제임이 구조적으로 설명됨</a:t>
+            </a:r>
+          </a:p>
+        </p:txBody>
+      </p:sp>
+    </p:spTree>
+  </p:cSld>
+  <p:clrMapOvr>
+    <a:masterClrMapping/>
+  </p:clrMapOvr>
+</p:sld>
+</file>
+
+<file path=ppt/slides/slide5.xml><?xml version="1.0" encoding="utf-8"?>
+<p:sld xmlns:a="http://schemas.openxmlformats.org/drawingml/2006/main" xmlns:p="http://schemas.openxmlformats.org/presentationml/2006/main" xmlns:r="http://schemas.openxmlformats.org/officeDocument/2006/relationships">
+  <p:cSld>
+    <p:spTree>
+      <p:nvGrpSpPr>
+        <p:cNvPr id="1" name=""/>
+        <p:cNvGrpSpPr/>
+        <p:nvPr/>
+      </p:nvGrpSpPr>
+      <p:grpSpPr/>
+      <p:sp>
+        <p:nvSpPr>
+          <p:cNvPr id="2" name="TextBox 1"/>
+          <p:cNvSpPr txBox="1"/>
+          <p:nvPr/>
+        </p:nvSpPr>
+        <p:spPr>
+          <a:xfrm>
+            <a:off x="365760" y="109728"/>
+            <a:ext cx="11430000" cy="914400"/>
+          </a:xfrm>
+          <a:prstGeom prst="rect">
+            <a:avLst/>
+          </a:prstGeom>
+          <a:noFill/>
+        </p:spPr>
+        <p:txBody>
+          <a:bodyPr wrap="none">
+            <a:spAutoFit/>
+          </a:bodyPr>
+          <a:lstStyle/>
+          <a:p>
+            <a:pPr>
+              <a:defRPr sz="2600" b="1"/>
+            </a:pPr>
+            <a:r>
+              <a:t>최종 확정: NV1 / NV2 ¹³C 핵스핀 목록</a:t>
+            </a:r>
+          </a:p>
+          <a:p>
+            <a:pPr>
+              <a:defRPr sz="1200"/>
+            </a:pPr>
+            <a:r>
+              <a:t>값 = (A∥ ± 95% CI, A⊥) kHz · ✅✅ 최고신뢰(전원+앵커) ✅ 확정 ⭕ 신뢰 ⚠ 보류</a:t>
+            </a:r>
+          </a:p>
+          <a:p>
+            <a:pPr>
+              <a:defRPr sz="1400" b="1">
+                <a:solidFill>
+                  <a:srgbClr val="B45000"/>
+                </a:solidFill>
+              </a:defRPr>
+            </a:pPr>
+            <a:r>
+              <a:t>▶ NV1 14개 + NV2 9개(+1 보류) — 물리·통계·교차검증 전부 통과, 수동 분석 7개 전원 재발견</a:t>
+            </a:r>
+          </a:p>
+        </p:txBody>
+      </p:sp>
+      <p:sp>
+        <p:nvSpPr>
+          <p:cNvPr id="3" name="TextBox 2"/>
+          <p:cNvSpPr txBox="1"/>
+          <p:nvPr/>
+        </p:nvSpPr>
+        <p:spPr>
+          <a:xfrm>
+            <a:off x="320040" y="1371600"/>
+            <a:ext cx="2834640" cy="274320"/>
+          </a:xfrm>
+          <a:prstGeom prst="rect">
+            <a:avLst/>
+          </a:prstGeom>
+          <a:noFill/>
+        </p:spPr>
+        <p:txBody>
+          <a:bodyPr wrap="none">
+            <a:spAutoFit/>
+          </a:bodyPr>
+          <a:lstStyle/>
+          <a:p>
+            <a:pPr>
+              <a:defRPr sz="1300" b="1"/>
+            </a:pPr>
+            <a:r>
+              <a:t>NV1 — 14개 (1/2)</a:t>
+            </a:r>
+          </a:p>
+        </p:txBody>
+      </p:sp>
+      <p:graphicFrame>
+        <p:nvGraphicFramePr>
+          <p:cNvPr id="4" name="Table 3"/>
+          <p:cNvGraphicFramePr>
+            <a:graphicFrameLocks noGrp="1"/>
+          </p:cNvGraphicFramePr>
+          <p:nvPr/>
+        </p:nvGraphicFramePr>
+        <p:xfrm>
+          <a:off x="320040" y="1691640"/>
+          <a:ext cx="2834640" cy="2688336"/>
+        </p:xfrm>
+        <a:graphic>
+          <a:graphicData uri="http://schemas.openxmlformats.org/drawingml/2006/table">
+            <a:tbl>
+              <a:tblPr firstRow="1" bandRow="1">
+                <a:tableStyleId>{5C22544A-7EE6-4342-B048-85BDC9FD1C3A}</a:tableStyleId>
+              </a:tblPr>
+              <a:tblGrid>
+                <a:gridCol w="2834640"/>
+              </a:tblGrid>
+              <a:tr h="384048">
+                <a:tc>
+                  <a:txBody>
+                    <a:bodyPr/>
+                    <a:lstStyle/>
+                    <a:p>
+                      <a:pPr>
+                        <a:defRPr sz="1050"/>
+                      </a:pPr>
+                      <a:r>
+                        <a:t>(−87.9 ±0.9, 18.3) ✅</a:t>
+                      </a:r>
+                    </a:p>
+                  </a:txBody>
+                  <a:tcPr/>
+                </a:tc>
+              </a:tr>
+              <a:tr h="384048">
+                <a:tc>
+                  <a:txBody>
+                    <a:bodyPr/>
+                    <a:lstStyle/>
+                    <a:p>
+                      <a:pPr>
+                        <a:defRPr sz="1050"/>
+                      </a:pPr>
+                      <a:r>
+                        <a:t>(−18.8 ±1.2, 15.5) ✅</a:t>
+                      </a:r>
+                    </a:p>
+                  </a:txBody>
+                  <a:tcPr/>
+                </a:tc>
+              </a:tr>
+              <a:tr h="384048">
+                <a:tc>
+                  <a:txBody>
+                    <a:bodyPr/>
+                    <a:lstStyle/>
+                    <a:p>
+                      <a:pPr>
+                        <a:defRPr sz="1050"/>
+                      </a:pPr>
+                      <a:r>
+                        <a:t>(−11.5 ±1.7, 13.9) ✅</a:t>
+                      </a:r>
+                    </a:p>
+                  </a:txBody>
+                  <a:tcPr/>
+                </a:tc>
+              </a:tr>
+              <a:tr h="384048">
+                <a:tc>
+                  <a:txBody>
+                    <a:bodyPr/>
+                    <a:lstStyle/>
+                    <a:p>
+                      <a:pPr>
+                        <a:defRPr sz="1050"/>
+                      </a:pPr>
+                      <a:r>
+                        <a:t>(−5.1 ±0.6, 22.5) ✅✅</a:t>
+                      </a:r>
+                    </a:p>
+                  </a:txBody>
+                  <a:tcPr/>
+                </a:tc>
+              </a:tr>
+              <a:tr h="384048">
+                <a:tc>
+                  <a:txBody>
+                    <a:bodyPr/>
+                    <a:lstStyle/>
+                    <a:p>
+                      <a:pPr>
+                        <a:defRPr sz="1050"/>
+                      </a:pPr>
+                      <a:r>
+                        <a:t>(+0.6 ±1.5, 17.1) ✅</a:t>
+                      </a:r>
+                    </a:p>
+                  </a:txBody>
+                  <a:tcPr/>
+                </a:tc>
+              </a:tr>
+              <a:tr h="384048">
+                <a:tc>
+                  <a:txBody>
+                    <a:bodyPr/>
+                    <a:lstStyle/>
+                    <a:p>
+                      <a:pPr>
+                        <a:defRPr sz="1050"/>
+                      </a:pPr>
+                      <a:r>
+                        <a:t>(+4.0 ±0.7, 26.2) ✅</a:t>
+                      </a:r>
+                    </a:p>
+                  </a:txBody>
+                  <a:tcPr/>
+                </a:tc>
+              </a:tr>
+              <a:tr h="384048">
+                <a:tc>
+                  <a:txBody>
+                    <a:bodyPr/>
+                    <a:lstStyle/>
+                    <a:p>
+                      <a:pPr>
+                        <a:defRPr sz="1050"/>
+                      </a:pPr>
+                      <a:r>
+                        <a:t>(+8.4 ±0.6, 27.8) ✅✅</a:t>
+                      </a:r>
+                    </a:p>
+                  </a:txBody>
+                  <a:tcPr/>
+                </a:tc>
+              </a:tr>
+            </a:tbl>
+          </a:graphicData>
+        </a:graphic>
+      </p:graphicFrame>
+      <p:sp>
+        <p:nvSpPr>
+          <p:cNvPr id="5" name="TextBox 4"/>
+          <p:cNvSpPr txBox="1"/>
+          <p:nvPr/>
+        </p:nvSpPr>
+        <p:spPr>
+          <a:xfrm>
+            <a:off x="3291840" y="1371600"/>
+            <a:ext cx="2834640" cy="274320"/>
+          </a:xfrm>
+          <a:prstGeom prst="rect">
+            <a:avLst/>
+          </a:prstGeom>
+          <a:noFill/>
+        </p:spPr>
+        <p:txBody>
+          <a:bodyPr wrap="none">
+            <a:spAutoFit/>
+          </a:bodyPr>
+          <a:lstStyle/>
+          <a:p>
+            <a:pPr>
+              <a:defRPr sz="1300" b="1"/>
+            </a:pPr>
+            <a:r>
+              <a:t>NV1 — 14개 (2/2)</a:t>
+            </a:r>
+          </a:p>
+        </p:txBody>
+      </p:sp>
+      <p:graphicFrame>
+        <p:nvGraphicFramePr>
+          <p:cNvPr id="6" name="Table 5"/>
+          <p:cNvGraphicFramePr>
+            <a:graphicFrameLocks noGrp="1"/>
+          </p:cNvGraphicFramePr>
+          <p:nvPr/>
+        </p:nvGraphicFramePr>
+        <p:xfrm>
+          <a:off x="3291840" y="1691640"/>
+          <a:ext cx="2834640" cy="2688336"/>
+        </p:xfrm>
+        <a:graphic>
+          <a:graphicData uri="http://schemas.openxmlformats.org/drawingml/2006/table">
+            <a:tbl>
+              <a:tblPr firstRow="1" bandRow="1">
+                <a:tableStyleId>{5C22544A-7EE6-4342-B048-85BDC9FD1C3A}</a:tableStyleId>
+              </a:tblPr>
+              <a:tblGrid>
+                <a:gridCol w="2834640"/>
+              </a:tblGrid>
+              <a:tr h="384048">
+                <a:tc>
+                  <a:txBody>
+                    <a:bodyPr/>
+                    <a:lstStyle/>
+                    <a:p>
+                      <a:pPr>
+                        <a:defRPr sz="1050"/>
+                      </a:pPr>
+                      <a:r>
+                        <a:t>(+14.2 ±1.0, 21.7) ✅</a:t>
+                      </a:r>
+                    </a:p>
+                  </a:txBody>
+                  <a:tcPr/>
+                </a:tc>
+              </a:tr>
+              <a:tr h="384048">
+                <a:tc>
+                  <a:txBody>
+                    <a:bodyPr/>
+                    <a:lstStyle/>
+                    <a:p>
+                      <a:pPr>
+                        <a:defRPr sz="1050"/>
+                      </a:pPr>
+                      <a:r>
+                        <a:t>(+24.3 ±1.5, 20.1) ✅</a:t>
+                      </a:r>
+                    </a:p>
+                  </a:txBody>
+                  <a:tcPr/>
+                </a:tc>
+              </a:tr>
+              <a:tr h="384048">
+                <a:tc>
+                  <a:txBody>
+                    <a:bodyPr/>
+                    <a:lstStyle/>
+                    <a:p>
+                      <a:pPr>
+                        <a:defRPr sz="1050"/>
+                      </a:pPr>
+                      <a:r>
+                        <a:t>(+39.0 ±2.0, 28.2) ✅✅</a:t>
+                      </a:r>
+                    </a:p>
+                  </a:txBody>
+                  <a:tcPr/>
+                </a:tc>
+              </a:tr>
+              <a:tr h="384048">
+                <a:tc>
+                  <a:txBody>
+                    <a:bodyPr/>
+                    <a:lstStyle/>
+                    <a:p>
+                      <a:pPr>
+                        <a:defRPr sz="1050"/>
+                      </a:pPr>
+                      <a:r>
+                        <a:t>(+48.0 ±2.6, 25.1) ✅</a:t>
+                      </a:r>
+                    </a:p>
+                  </a:txBody>
+                  <a:tcPr/>
+                </a:tc>
+              </a:tr>
+              <a:tr h="384048">
+                <a:tc>
+                  <a:txBody>
+                    <a:bodyPr/>
+                    <a:lstStyle/>
+                    <a:p>
+                      <a:pPr>
+                        <a:defRPr sz="1050"/>
+                      </a:pPr>
+                      <a:r>
+                        <a:t>(+65.6 ±1.0, 27.6) ✅</a:t>
+                      </a:r>
+                    </a:p>
+                  </a:txBody>
+                  <a:tcPr/>
+                </a:tc>
+              </a:tr>
+              <a:tr h="384048">
+                <a:tc>
+                  <a:txBody>
+                    <a:bodyPr/>
+                    <a:lstStyle/>
+                    <a:p>
+                      <a:pPr>
+                        <a:defRPr sz="1050"/>
+                      </a:pPr>
+                      <a:r>
+                        <a:t>(+91.9 ±0.7, 32.6) ✅</a:t>
+                      </a:r>
+                    </a:p>
+                  </a:txBody>
+                  <a:tcPr/>
+                </a:tc>
+              </a:tr>
+              <a:tr h="384048">
+                <a:tc>
+                  <a:txBody>
+                    <a:bodyPr/>
+                    <a:lstStyle/>
+                    <a:p>
+                      <a:pPr>
+                        <a:defRPr sz="1050"/>
+                      </a:pPr>
+                      <a:r>
+                        <a:t>(+114.4 ±1.7, 23.9) ✅</a:t>
+                      </a:r>
+                    </a:p>
+                  </a:txBody>
+                  <a:tcPr/>
+                </a:tc>
+              </a:tr>
+            </a:tbl>
+          </a:graphicData>
+        </a:graphic>
+      </p:graphicFrame>
+      <p:sp>
+        <p:nvSpPr>
+          <p:cNvPr id="7" name="TextBox 6"/>
+          <p:cNvSpPr txBox="1"/>
+          <p:nvPr/>
+        </p:nvSpPr>
+        <p:spPr>
+          <a:xfrm>
+            <a:off x="6720840" y="1371600"/>
+            <a:ext cx="2834640" cy="274320"/>
+          </a:xfrm>
+          <a:prstGeom prst="rect">
+            <a:avLst/>
+          </a:prstGeom>
+          <a:noFill/>
+        </p:spPr>
+        <p:txBody>
+          <a:bodyPr wrap="none">
+            <a:spAutoFit/>
+          </a:bodyPr>
+          <a:lstStyle/>
+          <a:p>
+            <a:pPr>
+              <a:defRPr sz="1300" b="1"/>
+            </a:pPr>
+            <a:r>
+              <a:t>NV2 — 9개 + 보류 1</a:t>
+            </a:r>
+          </a:p>
+        </p:txBody>
+      </p:sp>
+      <p:graphicFrame>
+        <p:nvGraphicFramePr>
+          <p:cNvPr id="8" name="Table 7"/>
+          <p:cNvGraphicFramePr>
+            <a:graphicFrameLocks noGrp="1"/>
+          </p:cNvGraphicFramePr>
+          <p:nvPr/>
+        </p:nvGraphicFramePr>
+        <p:xfrm>
+          <a:off x="6720840" y="1691640"/>
+          <a:ext cx="2834640" cy="1920240"/>
+        </p:xfrm>
+        <a:graphic>
+          <a:graphicData uri="http://schemas.openxmlformats.org/drawingml/2006/table">
+            <a:tbl>
+              <a:tblPr firstRow="1" bandRow="1">
+                <a:tableStyleId>{5C22544A-7EE6-4342-B048-85BDC9FD1C3A}</a:tableStyleId>
+              </a:tblPr>
+              <a:tblGrid>
+                <a:gridCol w="2834640"/>
+              </a:tblGrid>
+              <a:tr h="384048">
+                <a:tc>
+                  <a:txBody>
+                    <a:bodyPr/>
+                    <a:lstStyle/>
+                    <a:p>
+                      <a:pPr>
+                        <a:defRPr sz="1050"/>
+                      </a:pPr>
+                      <a:r>
+                        <a:t>(+346.9, 261) ✅✅</a:t>
+                      </a:r>
+                    </a:p>
+                  </a:txBody>
+                  <a:tcPr/>
+                </a:tc>
+              </a:tr>
+              <a:tr h="384048">
+                <a:tc>
+                  <a:txBody>
+                    <a:bodyPr/>
+                    <a:lstStyle/>
+                    <a:p>
+                      <a:pPr>
+                        <a:defRPr sz="1050"/>
+                      </a:pPr>
+                      <a:r>
+                        <a:t>(−151.2, 95) ✅</a:t>
+                      </a:r>
+                    </a:p>
+                  </a:txBody>
+                  <a:tcPr/>
+                </a:tc>
+              </a:tr>
+              <a:tr h="384048">
+                <a:tc>
+                  <a:txBody>
+                    <a:bodyPr/>
+                    <a:lstStyle/>
+                    <a:p>
+                      <a:pPr>
+                        <a:defRPr sz="1050"/>
+                      </a:pPr>
+                      <a:r>
+                        <a:t>(−58.9, 182) ✅</a:t>
+                      </a:r>
+                    </a:p>
+                  </a:txBody>
+                  <a:tcPr/>
+                </a:tc>
+              </a:tr>
+              <a:tr h="384048">
+                <a:tc>
+                  <a:txBody>
+                    <a:bodyPr/>
+                    <a:lstStyle/>
+                    <a:p>
+                      <a:pPr>
+                        <a:defRPr sz="1050"/>
+                      </a:pPr>
+                      <a:r>
+                        <a:t>(−45.9, 50) ⭕</a:t>
+                      </a:r>
+                    </a:p>
+                  </a:txBody>
+                  <a:tcPr/>
+                </a:tc>
+              </a:tr>
+              <a:tr h="384048">
+                <a:tc>
+                  <a:txBody>
+                    <a:bodyPr/>
+                    <a:lstStyle/>
+                    <a:p>
+                      <a:pPr>
+                        <a:defRPr sz="1050"/>
+                      </a:pPr>
+                      <a:r>
+                        <a:t>(−38.9, 67) ✅✅</a:t>
+                      </a:r>
+                    </a:p>
+                  </a:txBody>
+                  <a:tcPr/>
+                </a:tc>
+              </a:tr>
+            </a:tbl>
+          </a:graphicData>
+        </a:graphic>
+      </p:graphicFrame>
+      <p:sp>
+        <p:nvSpPr>
+          <p:cNvPr id="9" name="TextBox 8"/>
+          <p:cNvSpPr txBox="1"/>
+          <p:nvPr/>
+        </p:nvSpPr>
+        <p:spPr>
+          <a:xfrm>
+            <a:off x="9692640" y="1371600"/>
+            <a:ext cx="2286000" cy="274320"/>
+          </a:xfrm>
+          <a:prstGeom prst="rect">
+            <a:avLst/>
+          </a:prstGeom>
+          <a:noFill/>
+        </p:spPr>
+        <p:txBody>
+          <a:bodyPr wrap="none">
+            <a:spAutoFit/>
+          </a:bodyPr>
+          <a:lstStyle/>
+          <a:p>
+            <a:pPr>
+              <a:defRPr sz="1300" b="1"/>
+            </a:pPr>
+            <a:r>
+              <a:t> </a:t>
+            </a:r>
+          </a:p>
+        </p:txBody>
+      </p:sp>
+      <p:graphicFrame>
+        <p:nvGraphicFramePr>
+          <p:cNvPr id="10" name="Table 9"/>
+          <p:cNvGraphicFramePr>
+            <a:graphicFrameLocks noGrp="1"/>
+          </p:cNvGraphicFramePr>
+          <p:nvPr/>
+        </p:nvGraphicFramePr>
+        <p:xfrm>
+          <a:off x="9692640" y="1691640"/>
+          <a:ext cx="2286000" cy="1920240"/>
+        </p:xfrm>
+        <a:graphic>
+          <a:graphicData uri="http://schemas.openxmlformats.org/drawingml/2006/table">
+            <a:tbl>
+              <a:tblPr firstRow="1" bandRow="1">
+                <a:tableStyleId>{5C22544A-7EE6-4342-B048-85BDC9FD1C3A}</a:tableStyleId>
+              </a:tblPr>
+              <a:tblGrid>
+                <a:gridCol w="2286000"/>
+              </a:tblGrid>
+              <a:tr h="384048">
+                <a:tc>
+                  <a:txBody>
+                    <a:bodyPr/>
+                    <a:lstStyle/>
+                    <a:p>
+                      <a:pPr>
+                        <a:defRPr sz="1050"/>
+                      </a:pPr>
+                      <a:r>
+                        <a:t>(−12.6, 42) ✅</a:t>
+                      </a:r>
+                    </a:p>
+                  </a:txBody>
+                  <a:tcPr/>
+                </a:tc>
+              </a:tr>
+              <a:tr h="384048">
+                <a:tc>
+                  <a:txBody>
+                    <a:bodyPr/>
+                    <a:lstStyle/>
+                    <a:p>
+                      <a:pPr>
+                        <a:defRPr sz="1050"/>
+                      </a:pPr>
+                      <a:r>
+                        <a:t>(−2.7, 37) ⭕</a:t>
+                      </a:r>
+                    </a:p>
+                  </a:txBody>
+                  <a:tcPr/>
+                </a:tc>
+              </a:tr>
+              <a:tr h="384048">
+                <a:tc>
+                  <a:txBody>
+                    <a:bodyPr/>
+                    <a:lstStyle/>
+                    <a:p>
+                      <a:pPr>
+                        <a:defRPr sz="1050"/>
+                      </a:pPr>
+                      <a:r>
+                        <a:t>(+51.7, 91) ✅</a:t>
+                      </a:r>
+                    </a:p>
+                  </a:txBody>
+                  <a:tcPr/>
+                </a:tc>
+              </a:tr>
+              <a:tr h="384048">
+                <a:tc>
+                  <a:txBody>
+                    <a:bodyPr/>
+                    <a:lstStyle/>
+                    <a:p>
+                      <a:pPr>
+                        <a:defRPr sz="1050"/>
+                      </a:pPr>
+                      <a:r>
+                        <a:t>(+55.9, 55) ✅</a:t>
+                      </a:r>
+                    </a:p>
+                  </a:txBody>
+                  <a:tcPr/>
+                </a:tc>
+              </a:tr>
+              <a:tr h="384048">
+                <a:tc>
+                  <a:txBody>
+                    <a:bodyPr/>
+                    <a:lstStyle/>
+                    <a:p>
+                      <a:pPr>
+                        <a:defRPr sz="1050"/>
+                      </a:pPr>
+                      <a:r>
+                        <a:t>(+430.7, 58) ⚠ 보류</a:t>
+                      </a:r>
+                    </a:p>
+                  </a:txBody>
+                  <a:tcPr/>
+                </a:tc>
+              </a:tr>
+            </a:tbl>
+          </a:graphicData>
+        </a:graphic>
+      </p:graphicFrame>
+      <p:sp>
+        <p:nvSpPr>
+          <p:cNvPr id="11" name="TextBox 10"/>
+          <p:cNvSpPr txBox="1"/>
+          <p:nvPr/>
+        </p:nvSpPr>
+        <p:spPr>
+          <a:xfrm>
+            <a:off x="365760" y="4709160"/>
+            <a:ext cx="11430000" cy="1920240"/>
+          </a:xfrm>
+          <a:prstGeom prst="rect">
+            <a:avLst/>
+          </a:prstGeom>
+          <a:noFill/>
+        </p:spPr>
+        <p:txBody>
+          <a:bodyPr wrap="square">
+            <a:spAutoFit/>
+          </a:bodyPr>
+          <a:lstStyle/>
+          <a:p>
+            <a:pPr>
+              <a:defRPr sz="1150"/>
+            </a:pPr>
+            <a:r>
+              <a:t>• 개수 근거 — BIC 최소 k*=14, RJMCMC 사후 최빈 15와 정합 · 스핀 추가 벌점 통과분만 채택</a:t>
+            </a:r>
+          </a:p>
+          <a:p>
+            <a:pPr>
+              <a:defRPr sz="1150"/>
+            </a:pPr>
+            <a:r>
+              <a:t>• 통계적 실체 — 14개 전부 95% CI 상호 비겹침 (부트스트랩 60회)</a:t>
+            </a:r>
+          </a:p>
+          <a:p>
+            <a:pPr>
+              <a:defRPr sz="1150"/>
+            </a:pPr>
+            <a:r>
+              <a:t>• 물리 재현 — 단일 목록으로 N=8/16/20 세 측정 동시 설명, RMSE 0.088/0.116/0.176 (노이즈 바닥 도달)</a:t>
+            </a:r>
+          </a:p>
+          <a:p>
+            <a:pPr>
+              <a:defRPr sz="1150"/>
+            </a:pPr>
+            <a:r>
+              <a:t>• 외부 정합 — 수동 분석 앵커 NV1 4/4 · NV2 3/3 회수 (부호는 m_s 브랜치 관례 차이)</a:t>
+            </a:r>
+          </a:p>
+          <a:p>
+            <a:pPr>
+              <a:defRPr sz="1150"/>
+            </a:pPr>
+            <a:r>
+              <a:t>• NV2 주의 — 단일 채널(CPMG-16)이라 A⊥는 대표값 · (+430.7) 축퇴 잔재 가능, CPMG-8/20 추가 측정 시 판정</a:t>
+            </a:r>
+          </a:p>
+          <a:p>
+            <a:pPr>
+              <a:defRPr sz="1150"/>
+            </a:pPr>
+            <a:r>
+              <a:t>• 목록 외 후보 — NV1 A≈−32±3 (3계열 지지, 최종 피팅 미포함)</a:t>
             </a:r>
           </a:p>
         </p:txBody>

</xml_diff>

<commit_message>
Summary deck: head-to-head '2021 vs ours' slide; other models framed as ablations/baselines
Co-Authored-By: Claude Fable 5 <noreply@anthropic.com>
</commit_message>
<xml_diff>
--- a/results/NV_C13_summary_3slides.pptx
+++ b/results/NV_C13_summary_3slides.pptx
@@ -10,6 +10,7 @@
     <p:sldId id="258" r:id="rId9"/>
     <p:sldId id="259" r:id="rId10"/>
     <p:sldId id="260" r:id="rId11"/>
+    <p:sldId id="261" r:id="rId12"/>
   </p:sldIdLst>
   <p:sldSz cx="12191695" cy="6858000" type="screen4x3"/>
   <p:notesSz cx="6858000" cy="9144000"/>
@@ -3743,6 +3744,515 @@
               <a:defRPr sz="2600" b="1"/>
             </a:pPr>
             <a:r>
+              <a:t>정면 비교: 2021 방법 vs 우리 방법</a:t>
+            </a:r>
+          </a:p>
+          <a:p>
+            <a:pPr>
+              <a:defRPr sz="1200"/>
+            </a:pPr>
+            <a:r>
+              <a:t>나머지 모델들(CNN뱅크·SpinDETR·PF단독·DE·RJMCMC)은 이 결론을 떠받치는 ablation·베이스라인</a:t>
+            </a:r>
+          </a:p>
+          <a:p>
+            <a:pPr>
+              <a:defRPr sz="1400" b="1">
+                <a:solidFill>
+                  <a:srgbClr val="B45000"/>
+                </a:solidFill>
+              </a:defRPr>
+            </a:pPr>
+            <a:r>
+              <a:t>▶ 같은 실측 스핀 환경에서 채점한 결과 — 저온 ×2.2, 상온 ×1.5, 오차주입 ×1.7</a:t>
+            </a:r>
+          </a:p>
+        </p:txBody>
+      </p:sp>
+      <p:graphicFrame>
+        <p:nvGraphicFramePr>
+          <p:cNvPr id="3" name="Table 2"/>
+          <p:cNvGraphicFramePr>
+            <a:graphicFrameLocks noGrp="1"/>
+          </p:cNvGraphicFramePr>
+          <p:nvPr/>
+        </p:nvGraphicFramePr>
+        <p:xfrm>
+          <a:off x="365760" y="1463040"/>
+          <a:ext cx="11475720" cy="4937760"/>
+        </p:xfrm>
+        <a:graphic>
+          <a:graphicData uri="http://schemas.openxmlformats.org/drawingml/2006/table">
+            <a:tbl>
+              <a:tblPr firstRow="1" bandRow="1">
+                <a:tableStyleId>{5C22544A-7EE6-4342-B048-85BDC9FD1C3A}</a:tableStyleId>
+              </a:tblPr>
+              <a:tblGrid>
+                <a:gridCol w="2011680"/>
+                <a:gridCol w="4480560"/>
+                <a:gridCol w="4983480"/>
+              </a:tblGrid>
+              <a:tr h="705394">
+                <a:tc>
+                  <a:txBody>
+                    <a:bodyPr/>
+                    <a:lstStyle/>
+                    <a:p>
+                      <a:pPr>
+                        <a:defRPr sz="1300" b="1"/>
+                      </a:pPr>
+                    </a:p>
+                  </a:txBody>
+                  <a:tcPr/>
+                </a:tc>
+                <a:tc>
+                  <a:txBody>
+                    <a:bodyPr/>
+                    <a:lstStyle/>
+                    <a:p>
+                      <a:pPr>
+                        <a:defRPr sz="1300" b="1"/>
+                      </a:pPr>
+                      <a:r>
+                        <a:t>2021 방법 (core-pipeline 재현)</a:t>
+                      </a:r>
+                    </a:p>
+                  </a:txBody>
+                  <a:tcPr>
+                    <a:solidFill>
+                      <a:srgbClr val="F2D5CC"/>
+                    </a:solidFill>
+                  </a:tcPr>
+                </a:tc>
+                <a:tc>
+                  <a:txBody>
+                    <a:bodyPr/>
+                    <a:lstStyle/>
+                    <a:p>
+                      <a:pPr>
+                        <a:defRPr sz="1300" b="1"/>
+                      </a:pPr>
+                      <a:r>
+                        <a:t>우리 방법 (PF→RJMCMC 하이브리드 v2)</a:t>
+                      </a:r>
+                    </a:p>
+                  </a:txBody>
+                  <a:tcPr>
+                    <a:solidFill>
+                      <a:srgbClr val="D9EAD3"/>
+                    </a:solidFill>
+                  </a:tcPr>
+                </a:tc>
+              </a:tr>
+              <a:tr h="705394">
+                <a:tc>
+                  <a:txBody>
+                    <a:bodyPr/>
+                    <a:lstStyle/>
+                    <a:p>
+                      <a:pPr>
+                        <a:defRPr sz="1100" b="1"/>
+                      </a:pPr>
+                      <a:r>
+                        <a:t>구조</a:t>
+                      </a:r>
+                    </a:p>
+                  </a:txBody>
+                  <a:tcPr/>
+                </a:tc>
+                <a:tc>
+                  <a:txBody>
+                    <a:bodyPr/>
+                    <a:lstStyle/>
+                    <a:p>
+                      <a:pPr>
+                        <a:defRPr sz="1100"/>
+                      </a:pPr>
+                      <a:r>
+                        <a:t>윈도우별 독립 MLP 61개</a:t>
+                      </a:r>
+                    </a:p>
+                    <a:p>
+                      <a:pPr>
+                        <a:defRPr sz="1100"/>
+                      </a:pPr>
+                      <a:r>
+                        <a:t>+ 별도 디노이저</a:t>
+                      </a:r>
+                    </a:p>
+                  </a:txBody>
+                  <a:tcPr/>
+                </a:tc>
+                <a:tc>
+                  <a:txBody>
+                    <a:bodyPr/>
+                    <a:lstStyle/>
+                    <a:p>
+                      <a:pPr>
+                        <a:defRPr sz="1100"/>
+                      </a:pPr>
+                      <a:r>
+                        <a:t>신경망 탐지(윈도우 간 어텐션)</a:t>
+                      </a:r>
+                    </a:p>
+                    <a:p>
+                      <a:pPr>
+                        <a:defRPr sz="1100"/>
+                      </a:pPr>
+                      <a:r>
+                        <a:t>+ 영역 제약 물리 피팅 + BIC</a:t>
+                      </a:r>
+                    </a:p>
+                  </a:txBody>
+                  <a:tcPr/>
+                </a:tc>
+              </a:tr>
+              <a:tr h="705394">
+                <a:tc>
+                  <a:txBody>
+                    <a:bodyPr/>
+                    <a:lstStyle/>
+                    <a:p>
+                      <a:pPr>
+                        <a:defRPr sz="1100" b="1"/>
+                      </a:pPr>
+                      <a:r>
+                        <a:t>출력</a:t>
+                      </a:r>
+                    </a:p>
+                  </a:txBody>
+                  <a:tcPr/>
+                </a:tc>
+                <a:tc>
+                  <a:txBody>
+                    <a:bodyPr/>
+                    <a:lstStyle/>
+                    <a:p>
+                      <a:pPr>
+                        <a:defRPr sz="1100"/>
+                      </a:pPr>
+                      <a:r>
+                        <a:t>고확률 영역 (A 위치 후보)</a:t>
+                      </a:r>
+                    </a:p>
+                    <a:p>
+                      <a:pPr>
+                        <a:defRPr sz="1100"/>
+                      </a:pPr>
+                      <a:r>
+                        <a:t>B·개수는 별도 단계 필요</a:t>
+                      </a:r>
+                    </a:p>
+                  </a:txBody>
+                  <a:tcPr/>
+                </a:tc>
+                <a:tc>
+                  <a:txBody>
+                    <a:bodyPr/>
+                    <a:lstStyle/>
+                    <a:p>
+                      <a:pPr>
+                        <a:defRPr sz="1100"/>
+                      </a:pPr>
+                      <a:r>
+                        <a:t>최종 스핀 목록 {(A∥, A⊥)} × k*</a:t>
+                      </a:r>
+                    </a:p>
+                    <a:p>
+                      <a:pPr>
+                        <a:defRPr sz="1100"/>
+                      </a:pPr>
+                      <a:r>
+                        <a:t>개수 자동 · 95% CI 제공</a:t>
+                      </a:r>
+                    </a:p>
+                  </a:txBody>
+                  <a:tcPr/>
+                </a:tc>
+              </a:tr>
+              <a:tr h="705394">
+                <a:tc>
+                  <a:txBody>
+                    <a:bodyPr/>
+                    <a:lstStyle/>
+                    <a:p>
+                      <a:pPr>
+                        <a:defRPr sz="1100" b="1"/>
+                      </a:pPr>
+                      <a:r>
+                        <a:t>실측 50-스핀 검증 (F1)</a:t>
+                      </a:r>
+                    </a:p>
+                  </a:txBody>
+                  <a:tcPr/>
+                </a:tc>
+                <a:tc>
+                  <a:txBody>
+                    <a:bodyPr/>
+                    <a:lstStyle/>
+                    <a:p>
+                      <a:pPr>
+                        <a:defRPr sz="1100"/>
+                      </a:pPr>
+                      <a:r>
+                        <a:t>저온 0.38 · 상온 0.37 · 오차주입 0.35</a:t>
+                      </a:r>
+                    </a:p>
+                  </a:txBody>
+                  <a:tcPr/>
+                </a:tc>
+                <a:tc>
+                  <a:txBody>
+                    <a:bodyPr/>
+                    <a:lstStyle/>
+                    <a:p>
+                      <a:pPr>
+                        <a:defRPr sz="1100"/>
+                      </a:pPr>
+                      <a:r>
+                        <a:t>저온 0.84 · 상온 0.57 · 오차주입 0.61</a:t>
+                      </a:r>
+                    </a:p>
+                  </a:txBody>
+                  <a:tcPr/>
+                </a:tc>
+              </a:tr>
+              <a:tr h="705394">
+                <a:tc>
+                  <a:txBody>
+                    <a:bodyPr/>
+                    <a:lstStyle/>
+                    <a:p>
+                      <a:pPr>
+                        <a:defRPr sz="1100" b="1"/>
+                      </a:pPr>
+                      <a:r>
+                        <a:t>오탐 (precision)</a:t>
+                      </a:r>
+                    </a:p>
+                  </a:txBody>
+                  <a:tcPr/>
+                </a:tc>
+                <a:tc>
+                  <a:txBody>
+                    <a:bodyPr/>
+                    <a:lstStyle/>
+                    <a:p>
+                      <a:pPr>
+                        <a:defRPr sz="1100"/>
+                      </a:pPr>
+                      <a:r>
+                        <a:t>0.55–1.00 (상온에서 붕괴)</a:t>
+                      </a:r>
+                    </a:p>
+                  </a:txBody>
+                  <a:tcPr/>
+                </a:tc>
+                <a:tc>
+                  <a:txBody>
+                    <a:bodyPr/>
+                    <a:lstStyle/>
+                    <a:p>
+                      <a:pPr>
+                        <a:defRPr sz="1100"/>
+                      </a:pPr>
+                      <a:r>
+                        <a:t>0.87–1.00 (오차주입에도 0.87)</a:t>
+                      </a:r>
+                    </a:p>
+                  </a:txBody>
+                  <a:tcPr/>
+                </a:tc>
+              </a:tr>
+              <a:tr h="705394">
+                <a:tc>
+                  <a:txBody>
+                    <a:bodyPr/>
+                    <a:lstStyle/>
+                    <a:p>
+                      <a:pPr>
+                        <a:defRPr sz="1100" b="1"/>
+                      </a:pPr>
+                      <a:r>
+                        <a:t>실데이터 NV1</a:t>
+                      </a:r>
+                    </a:p>
+                  </a:txBody>
+                  <a:tcPr/>
+                </a:tc>
+                <a:tc>
+                  <a:txBody>
+                    <a:bodyPr/>
+                    <a:lstStyle/>
+                    <a:p>
+                      <a:pPr>
+                        <a:defRPr sz="1100"/>
+                      </a:pPr>
+                      <a:r>
+                        <a:t>고확률 영역 2곳 + 피크 3개</a:t>
+                      </a:r>
+                    </a:p>
+                    <a:p>
+                      <a:pPr>
+                        <a:defRPr sz="1100"/>
+                      </a:pPr>
+                      <a:r>
+                        <a:t>(개별 스핀 분해 불가)</a:t>
+                      </a:r>
+                    </a:p>
+                  </a:txBody>
+                  <a:tcPr/>
+                </a:tc>
+                <a:tc>
+                  <a:txBody>
+                    <a:bodyPr/>
+                    <a:lstStyle/>
+                    <a:p>
+                      <a:pPr>
+                        <a:defRPr sz="1100"/>
+                      </a:pPr>
+                      <a:r>
+                        <a:t>14개 스핀 확정 (CI 포함)</a:t>
+                      </a:r>
+                    </a:p>
+                    <a:p>
+                      <a:pPr>
+                        <a:defRPr sz="1100"/>
+                      </a:pPr>
+                      <a:r>
+                        <a:t>3개 측정 동시 재현 RMSE 0.09–0.18</a:t>
+                      </a:r>
+                    </a:p>
+                  </a:txBody>
+                  <a:tcPr/>
+                </a:tc>
+              </a:tr>
+              <a:tr h="705396">
+                <a:tc>
+                  <a:txBody>
+                    <a:bodyPr/>
+                    <a:lstStyle/>
+                    <a:p>
+                      <a:pPr>
+                        <a:defRPr sz="1100" b="1"/>
+                      </a:pPr>
+                      <a:r>
+                        <a:t>전제 조건</a:t>
+                      </a:r>
+                    </a:p>
+                  </a:txBody>
+                  <a:tcPr/>
+                </a:tc>
+                <a:tc>
+                  <a:txBody>
+                    <a:bodyPr/>
+                    <a:lstStyle/>
+                    <a:p>
+                      <a:pPr>
+                        <a:defRPr sz="1100"/>
+                      </a:pPr>
+                      <a:r>
+                        <a:t>저온·고SNR·N=32/256 장시간 측정</a:t>
+                      </a:r>
+                    </a:p>
+                  </a:txBody>
+                  <a:tcPr/>
+                </a:tc>
+                <a:tc>
+                  <a:txBody>
+                    <a:bodyPr/>
+                    <a:lstStyle/>
+                    <a:p>
+                      <a:pPr>
+                        <a:defRPr sz="1100"/>
+                      </a:pPr>
+                      <a:r>
+                        <a:t>상온·700점·N≤20에서 작동</a:t>
+                      </a:r>
+                    </a:p>
+                  </a:txBody>
+                  <a:tcPr/>
+                </a:tc>
+              </a:tr>
+            </a:tbl>
+          </a:graphicData>
+        </a:graphic>
+      </p:graphicFrame>
+      <p:sp>
+        <p:nvSpPr>
+          <p:cNvPr id="4" name="TextBox 3"/>
+          <p:cNvSpPr txBox="1"/>
+          <p:nvPr/>
+        </p:nvSpPr>
+        <p:spPr>
+          <a:xfrm>
+            <a:off x="365760" y="6473952"/>
+            <a:ext cx="11430000" cy="347472"/>
+          </a:xfrm>
+          <a:prstGeom prst="rect">
+            <a:avLst/>
+          </a:prstGeom>
+          <a:noFill/>
+        </p:spPr>
+        <p:txBody>
+          <a:bodyPr wrap="none">
+            <a:spAutoFit/>
+          </a:bodyPr>
+          <a:lstStyle/>
+          <a:p>
+            <a:pPr>
+              <a:defRPr sz="1050"/>
+            </a:pPr>
+            <a:r>
+              <a:t>• 공정성 — 2021 수치는 core-pipeline 재현 기준(원방법 하한) · 두 방법 모두 같은 forward model·같은 채점 규칙</a:t>
+            </a:r>
+          </a:p>
+        </p:txBody>
+      </p:sp>
+    </p:spTree>
+  </p:cSld>
+  <p:clrMapOvr>
+    <a:masterClrMapping/>
+  </p:clrMapOvr>
+</p:sld>
+</file>
+
+<file path=ppt/slides/slide3.xml><?xml version="1.0" encoding="utf-8"?>
+<p:sld xmlns:a="http://schemas.openxmlformats.org/drawingml/2006/main" xmlns:p="http://schemas.openxmlformats.org/presentationml/2006/main" xmlns:r="http://schemas.openxmlformats.org/officeDocument/2006/relationships">
+  <p:cSld>
+    <p:spTree>
+      <p:nvGrpSpPr>
+        <p:cNvPr id="1" name=""/>
+        <p:cNvGrpSpPr/>
+        <p:nvPr/>
+      </p:nvGrpSpPr>
+      <p:grpSpPr/>
+      <p:sp>
+        <p:nvSpPr>
+          <p:cNvPr id="2" name="TextBox 1"/>
+          <p:cNvSpPr txBox="1"/>
+          <p:nvPr/>
+        </p:nvSpPr>
+        <p:spPr>
+          <a:xfrm>
+            <a:off x="365760" y="109728"/>
+            <a:ext cx="11430000" cy="914400"/>
+          </a:xfrm>
+          <a:prstGeom prst="rect">
+            <a:avLst/>
+          </a:prstGeom>
+          <a:noFill/>
+        </p:spPr>
+        <p:txBody>
+          <a:bodyPr wrap="none">
+            <a:spAutoFit/>
+          </a:bodyPr>
+          <a:lstStyle/>
+          <a:p>
+            <a:pPr>
+              <a:defRPr sz="2600" b="1"/>
+            </a:pPr>
+            <a:r>
               <a:t>요약 ②: 공개 실측 50-스핀 배스로 검증</a:t>
             </a:r>
           </a:p>
@@ -3831,7 +4341,7 @@
 </p:sld>
 </file>
 
-<file path=ppt/slides/slide3.xml><?xml version="1.0" encoding="utf-8"?>
+<file path=ppt/slides/slide4.xml><?xml version="1.0" encoding="utf-8"?>
 <p:sld xmlns:a="http://schemas.openxmlformats.org/drawingml/2006/main" xmlns:p="http://schemas.openxmlformats.org/presentationml/2006/main" xmlns:r="http://schemas.openxmlformats.org/officeDocument/2006/relationships">
   <p:cSld>
     <p:spTree>
@@ -3979,7 +4489,7 @@
 </p:sld>
 </file>
 
-<file path=ppt/slides/slide4.xml><?xml version="1.0" encoding="utf-8"?>
+<file path=ppt/slides/slide5.xml><?xml version="1.0" encoding="utf-8"?>
 <p:sld xmlns:a="http://schemas.openxmlformats.org/drawingml/2006/main" xmlns:p="http://schemas.openxmlformats.org/presentationml/2006/main" xmlns:r="http://schemas.openxmlformats.org/officeDocument/2006/relationships">
   <p:cSld>
     <p:spTree>
@@ -4847,7 +5357,7 @@
 </p:sld>
 </file>
 
-<file path=ppt/slides/slide5.xml><?xml version="1.0" encoding="utf-8"?>
+<file path=ppt/slides/slide6.xml><?xml version="1.0" encoding="utf-8"?>
 <p:sld xmlns:a="http://schemas.openxmlformats.org/drawingml/2006/main" xmlns:p="http://schemas.openxmlformats.org/presentationml/2006/main" xmlns:r="http://schemas.openxmlformats.org/officeDocument/2006/relationships">
   <p:cSld>
     <p:spTree>

</xml_diff>

<commit_message>
Summary deck: two-model block-diagram comparison slide (2021 vs ours)
Co-Authored-By: Claude Fable 5 <noreply@anthropic.com>
</commit_message>
<xml_diff>
--- a/results/NV_C13_summary_3slides.pptx
+++ b/results/NV_C13_summary_3slides.pptx
@@ -11,6 +11,7 @@
     <p:sldId id="259" r:id="rId10"/>
     <p:sldId id="260" r:id="rId11"/>
     <p:sldId id="261" r:id="rId12"/>
+    <p:sldId id="262" r:id="rId13"/>
   </p:sldIdLst>
   <p:sldSz cx="12191695" cy="6858000" type="screen4x3"/>
   <p:notesSz cx="6858000" cy="9144000"/>
@@ -4253,6 +4254,1672 @@
               <a:defRPr sz="2600" b="1"/>
             </a:pPr>
             <a:r>
+              <a:t>모델 비교: 블록 다이어그램</a:t>
+            </a:r>
+          </a:p>
+          <a:p>
+            <a:pPr>
+              <a:defRPr sz="1200"/>
+            </a:pPr>
+            <a:r>
+              <a:t>회색=입력 · 파랑=표현 · 초록=연산 · 주황=출력 — 위(2021) vs 아래(우리)</a:t>
+            </a:r>
+          </a:p>
+          <a:p>
+            <a:pPr>
+              <a:defRPr sz="1400" b="1">
+                <a:solidFill>
+                  <a:srgbClr val="B45000"/>
+                </a:solidFill>
+              </a:defRPr>
+            </a:pPr>
+            <a:r>
+              <a:t>▶ 구조적 차이 두 가지: ① 윈도우 61개가 고립 판정 vs 어텐션으로 회의  ② 영역 없는 피크 vs 영역 제약 열거(BIC)</a:t>
+            </a:r>
+          </a:p>
+        </p:txBody>
+      </p:sp>
+      <p:sp>
+        <p:nvSpPr>
+          <p:cNvPr id="3" name="TextBox 2"/>
+          <p:cNvSpPr txBox="1"/>
+          <p:nvPr/>
+        </p:nvSpPr>
+        <p:spPr>
+          <a:xfrm>
+            <a:off x="137160" y="1783080"/>
+            <a:ext cx="1600200" cy="914400"/>
+          </a:xfrm>
+          <a:prstGeom prst="rect">
+            <a:avLst/>
+          </a:prstGeom>
+          <a:noFill/>
+        </p:spPr>
+        <p:txBody>
+          <a:bodyPr wrap="square">
+            <a:spAutoFit/>
+          </a:bodyPr>
+          <a:lstStyle/>
+          <a:p>
+            <a:pPr>
+              <a:defRPr sz="1300" b="1">
+                <a:solidFill>
+                  <a:srgbClr val="8B3A2F"/>
+                </a:solidFill>
+              </a:defRPr>
+            </a:pPr>
+            <a:r>
+              <a:t>2021 방법</a:t>
+            </a:r>
+          </a:p>
+          <a:p>
+            <a:r>
+              <a:t>(core-pipeline)</a:t>
+            </a:r>
+          </a:p>
+        </p:txBody>
+      </p:sp>
+      <p:sp>
+        <p:nvSpPr>
+          <p:cNvPr id="4" name="Rounded Rectangle 3"/>
+          <p:cNvSpPr/>
+          <p:nvPr/>
+        </p:nvSpPr>
+        <p:spPr>
+          <a:xfrm>
+            <a:off x="1828800" y="1691640"/>
+            <a:ext cx="1325880" cy="868680"/>
+          </a:xfrm>
+          <a:prstGeom prst="roundRect">
+            <a:avLst/>
+          </a:prstGeom>
+          <a:solidFill>
+            <a:srgbClr val="E8E8E8"/>
+          </a:solidFill>
+          <a:ln>
+            <a:solidFill>
+              <a:srgbClr val="666666"/>
+            </a:solidFill>
+          </a:ln>
+          <a:effectLst/>
+        </p:spPr>
+        <p:style>
+          <a:lnRef idx="1">
+            <a:schemeClr val="accent1"/>
+          </a:lnRef>
+          <a:fillRef idx="3">
+            <a:schemeClr val="accent1"/>
+          </a:fillRef>
+          <a:effectRef idx="2">
+            <a:schemeClr val="accent1"/>
+          </a:effectRef>
+          <a:fontRef idx="minor">
+            <a:schemeClr val="lt1"/>
+          </a:fontRef>
+        </p:style>
+        <p:txBody>
+          <a:bodyPr rtlCol="0" anchor="ctr" wrap="square"/>
+          <a:lstStyle/>
+          <a:p>
+            <a:pPr algn="ctr">
+              <a:defRPr sz="1100" b="1">
+                <a:solidFill>
+                  <a:srgbClr val="1A1A1A"/>
+                </a:solidFill>
+              </a:defRPr>
+            </a:pPr>
+            <a:r>
+              <a:t>CPMG 신호</a:t>
+            </a:r>
+          </a:p>
+          <a:p>
+            <a:pPr algn="ctr">
+              <a:defRPr sz="850">
+                <a:solidFill>
+                  <a:srgbClr val="7A0000"/>
+                </a:solidFill>
+              </a:defRPr>
+            </a:pPr>
+            <a:r>
+              <a:t>1채널 (700,)</a:t>
+            </a:r>
+          </a:p>
+        </p:txBody>
+      </p:sp>
+      <p:sp>
+        <p:nvSpPr>
+          <p:cNvPr id="5" name="TextBox 4"/>
+          <p:cNvSpPr txBox="1"/>
+          <p:nvPr/>
+        </p:nvSpPr>
+        <p:spPr>
+          <a:xfrm>
+            <a:off x="1783080" y="2578608"/>
+            <a:ext cx="1417320" cy="411480"/>
+          </a:xfrm>
+          <a:prstGeom prst="rect">
+            <a:avLst/>
+          </a:prstGeom>
+          <a:noFill/>
+        </p:spPr>
+        <p:txBody>
+          <a:bodyPr wrap="square">
+            <a:spAutoFit/>
+          </a:bodyPr>
+          <a:lstStyle/>
+          <a:p>
+            <a:pPr algn="ctr">
+              <a:defRPr sz="800">
+                <a:solidFill>
+                  <a:srgbClr val="444444"/>
+                </a:solidFill>
+              </a:defRPr>
+            </a:pPr>
+            <a:r>
+              <a:t>저온·장시간 측정 전제</a:t>
+            </a:r>
+          </a:p>
+        </p:txBody>
+      </p:sp>
+      <p:cxnSp>
+        <p:nvCxnSpPr>
+          <p:cNvPr id="6" name="Connector 5"/>
+          <p:cNvCxnSpPr/>
+          <p:nvPr/>
+        </p:nvCxnSpPr>
+        <p:spPr>
+          <a:xfrm>
+            <a:off x="3172968" y="2125980"/>
+            <a:ext cx="237744" cy="0"/>
+          </a:xfrm>
+          <a:prstGeom prst="line">
+            <a:avLst/>
+          </a:prstGeom>
+          <a:ln w="28575">
+            <a:solidFill>
+              <a:srgbClr val="404040"/>
+            </a:solidFill>
+            <a:tailEnd type="triangle" w="med" len="med"/>
+          </a:ln>
+        </p:spPr>
+        <p:style>
+          <a:lnRef idx="2">
+            <a:schemeClr val="accent1"/>
+          </a:lnRef>
+          <a:fillRef idx="0">
+            <a:schemeClr val="accent1"/>
+          </a:fillRef>
+          <a:effectRef idx="1">
+            <a:schemeClr val="accent1"/>
+          </a:effectRef>
+          <a:fontRef idx="minor">
+            <a:schemeClr val="tx1"/>
+          </a:fontRef>
+        </p:style>
+      </p:cxnSp>
+      <p:sp>
+        <p:nvSpPr>
+          <p:cNvPr id="7" name="Rounded Rectangle 6"/>
+          <p:cNvSpPr/>
+          <p:nvPr/>
+        </p:nvSpPr>
+        <p:spPr>
+          <a:xfrm>
+            <a:off x="3429000" y="1691640"/>
+            <a:ext cx="1417320" cy="868680"/>
+          </a:xfrm>
+          <a:prstGeom prst="roundRect">
+            <a:avLst/>
+          </a:prstGeom>
+          <a:solidFill>
+            <a:srgbClr val="DBE9F8"/>
+          </a:solidFill>
+          <a:ln>
+            <a:solidFill>
+              <a:srgbClr val="666666"/>
+            </a:solidFill>
+          </a:ln>
+          <a:effectLst/>
+        </p:spPr>
+        <p:style>
+          <a:lnRef idx="1">
+            <a:schemeClr val="accent1"/>
+          </a:lnRef>
+          <a:fillRef idx="3">
+            <a:schemeClr val="accent1"/>
+          </a:fillRef>
+          <a:effectRef idx="2">
+            <a:schemeClr val="accent1"/>
+          </a:effectRef>
+          <a:fontRef idx="minor">
+            <a:schemeClr val="lt1"/>
+          </a:fontRef>
+        </p:style>
+        <p:txBody>
+          <a:bodyPr rtlCol="0" anchor="ctr" wrap="square"/>
+          <a:lstStyle/>
+          <a:p>
+            <a:pPr algn="ctr">
+              <a:defRPr sz="1100" b="1">
+                <a:solidFill>
+                  <a:srgbClr val="1A1A1A"/>
+                </a:solidFill>
+              </a:defRPr>
+            </a:pPr>
+            <a:r>
+              <a:t>주기 접기</a:t>
+            </a:r>
+          </a:p>
+          <a:p>
+            <a:pPr algn="ctr">
+              <a:defRPr sz="850">
+                <a:solidFill>
+                  <a:srgbClr val="7A0000"/>
+                </a:solidFill>
+              </a:defRPr>
+            </a:pPr>
+            <a:r>
+              <a:t>이미지 13×53</a:t>
+            </a:r>
+          </a:p>
+        </p:txBody>
+      </p:sp>
+      <p:sp>
+        <p:nvSpPr>
+          <p:cNvPr id="8" name="TextBox 7"/>
+          <p:cNvSpPr txBox="1"/>
+          <p:nvPr/>
+        </p:nvSpPr>
+        <p:spPr>
+          <a:xfrm>
+            <a:off x="3383280" y="2578608"/>
+            <a:ext cx="1508760" cy="411480"/>
+          </a:xfrm>
+          <a:prstGeom prst="rect">
+            <a:avLst/>
+          </a:prstGeom>
+          <a:noFill/>
+        </p:spPr>
+        <p:txBody>
+          <a:bodyPr wrap="square">
+            <a:spAutoFit/>
+          </a:bodyPr>
+          <a:lstStyle/>
+          <a:p>
+            <a:pPr algn="ctr">
+              <a:defRPr sz="800">
+                <a:solidFill>
+                  <a:srgbClr val="444444"/>
+                </a:solidFill>
+              </a:defRPr>
+            </a:pPr>
+            <a:r>
+              <a:t>후보 주기 1개씩</a:t>
+            </a:r>
+          </a:p>
+        </p:txBody>
+      </p:sp>
+      <p:cxnSp>
+        <p:nvCxnSpPr>
+          <p:cNvPr id="9" name="Connector 8"/>
+          <p:cNvCxnSpPr/>
+          <p:nvPr/>
+        </p:nvCxnSpPr>
+        <p:spPr>
+          <a:xfrm>
+            <a:off x="4864607" y="2125980"/>
+            <a:ext cx="237745" cy="0"/>
+          </a:xfrm>
+          <a:prstGeom prst="line">
+            <a:avLst/>
+          </a:prstGeom>
+          <a:ln w="28575">
+            <a:solidFill>
+              <a:srgbClr val="404040"/>
+            </a:solidFill>
+            <a:tailEnd type="triangle" w="med" len="med"/>
+          </a:ln>
+        </p:spPr>
+        <p:style>
+          <a:lnRef idx="2">
+            <a:schemeClr val="accent1"/>
+          </a:lnRef>
+          <a:fillRef idx="0">
+            <a:schemeClr val="accent1"/>
+          </a:fillRef>
+          <a:effectRef idx="1">
+            <a:schemeClr val="accent1"/>
+          </a:effectRef>
+          <a:fontRef idx="minor">
+            <a:schemeClr val="tx1"/>
+          </a:fontRef>
+        </p:style>
+      </p:cxnSp>
+      <p:sp>
+        <p:nvSpPr>
+          <p:cNvPr id="10" name="Rounded Rectangle 9"/>
+          <p:cNvSpPr/>
+          <p:nvPr/>
+        </p:nvSpPr>
+        <p:spPr>
+          <a:xfrm>
+            <a:off x="5120640" y="1691640"/>
+            <a:ext cx="1691640" cy="868680"/>
+          </a:xfrm>
+          <a:prstGeom prst="roundRect">
+            <a:avLst/>
+          </a:prstGeom>
+          <a:solidFill>
+            <a:srgbClr val="DFF2DF"/>
+          </a:solidFill>
+          <a:ln>
+            <a:solidFill>
+              <a:srgbClr val="666666"/>
+            </a:solidFill>
+          </a:ln>
+          <a:effectLst/>
+        </p:spPr>
+        <p:style>
+          <a:lnRef idx="1">
+            <a:schemeClr val="accent1"/>
+          </a:lnRef>
+          <a:fillRef idx="3">
+            <a:schemeClr val="accent1"/>
+          </a:fillRef>
+          <a:effectRef idx="2">
+            <a:schemeClr val="accent1"/>
+          </a:effectRef>
+          <a:fontRef idx="minor">
+            <a:schemeClr val="lt1"/>
+          </a:fontRef>
+        </p:style>
+        <p:txBody>
+          <a:bodyPr rtlCol="0" anchor="ctr" wrap="square"/>
+          <a:lstStyle/>
+          <a:p>
+            <a:pPr algn="ctr">
+              <a:defRPr sz="1100" b="1">
+                <a:solidFill>
+                  <a:srgbClr val="1A1A1A"/>
+                </a:solidFill>
+              </a:defRPr>
+            </a:pPr>
+            <a:r>
+              <a:t>MLP ×61</a:t>
+            </a:r>
+          </a:p>
+          <a:p>
+            <a:pPr algn="ctr">
+              <a:defRPr sz="850">
+                <a:solidFill>
+                  <a:srgbClr val="7A0000"/>
+                </a:solidFill>
+              </a:defRPr>
+            </a:pPr>
+            <a:r>
+              <a:t>윈도우별 독립</a:t>
+            </a:r>
+          </a:p>
+        </p:txBody>
+      </p:sp>
+      <p:sp>
+        <p:nvSpPr>
+          <p:cNvPr id="11" name="TextBox 10"/>
+          <p:cNvSpPr txBox="1"/>
+          <p:nvPr/>
+        </p:nvSpPr>
+        <p:spPr>
+          <a:xfrm>
+            <a:off x="5074920" y="2578608"/>
+            <a:ext cx="1783080" cy="411480"/>
+          </a:xfrm>
+          <a:prstGeom prst="rect">
+            <a:avLst/>
+          </a:prstGeom>
+          <a:noFill/>
+        </p:spPr>
+        <p:txBody>
+          <a:bodyPr wrap="square">
+            <a:spAutoFit/>
+          </a:bodyPr>
+          <a:lstStyle/>
+          <a:p>
+            <a:pPr algn="ctr">
+              <a:defRPr sz="800">
+                <a:solidFill>
+                  <a:srgbClr val="444444"/>
+                </a:solidFill>
+              </a:defRPr>
+            </a:pPr>
+            <a:r>
+              <a:t>서로 대화 없음 → 오탐</a:t>
+            </a:r>
+          </a:p>
+        </p:txBody>
+      </p:sp>
+      <p:cxnSp>
+        <p:nvCxnSpPr>
+          <p:cNvPr id="12" name="Connector 11"/>
+          <p:cNvCxnSpPr/>
+          <p:nvPr/>
+        </p:nvCxnSpPr>
+        <p:spPr>
+          <a:xfrm>
+            <a:off x="6830567" y="2125980"/>
+            <a:ext cx="237745" cy="0"/>
+          </a:xfrm>
+          <a:prstGeom prst="line">
+            <a:avLst/>
+          </a:prstGeom>
+          <a:ln w="28575">
+            <a:solidFill>
+              <a:srgbClr val="404040"/>
+            </a:solidFill>
+            <a:tailEnd type="triangle" w="med" len="med"/>
+          </a:ln>
+        </p:spPr>
+        <p:style>
+          <a:lnRef idx="2">
+            <a:schemeClr val="accent1"/>
+          </a:lnRef>
+          <a:fillRef idx="0">
+            <a:schemeClr val="accent1"/>
+          </a:fillRef>
+          <a:effectRef idx="1">
+            <a:schemeClr val="accent1"/>
+          </a:effectRef>
+          <a:fontRef idx="minor">
+            <a:schemeClr val="tx1"/>
+          </a:fontRef>
+        </p:style>
+      </p:cxnSp>
+      <p:sp>
+        <p:nvSpPr>
+          <p:cNvPr id="13" name="Rounded Rectangle 12"/>
+          <p:cNvSpPr/>
+          <p:nvPr/>
+        </p:nvSpPr>
+        <p:spPr>
+          <a:xfrm>
+            <a:off x="7086600" y="1691640"/>
+            <a:ext cx="1508760" cy="868680"/>
+          </a:xfrm>
+          <a:prstGeom prst="roundRect">
+            <a:avLst/>
+          </a:prstGeom>
+          <a:solidFill>
+            <a:srgbClr val="DFF2DF"/>
+          </a:solidFill>
+          <a:ln>
+            <a:solidFill>
+              <a:srgbClr val="666666"/>
+            </a:solidFill>
+          </a:ln>
+          <a:effectLst/>
+        </p:spPr>
+        <p:style>
+          <a:lnRef idx="1">
+            <a:schemeClr val="accent1"/>
+          </a:lnRef>
+          <a:fillRef idx="3">
+            <a:schemeClr val="accent1"/>
+          </a:fillRef>
+          <a:effectRef idx="2">
+            <a:schemeClr val="accent1"/>
+          </a:effectRef>
+          <a:fontRef idx="minor">
+            <a:schemeClr val="lt1"/>
+          </a:fontRef>
+        </p:style>
+        <p:txBody>
+          <a:bodyPr rtlCol="0" anchor="ctr" wrap="square"/>
+          <a:lstStyle/>
+          <a:p>
+            <a:pPr algn="ctr">
+              <a:defRPr sz="1100" b="1">
+                <a:solidFill>
+                  <a:srgbClr val="1A1A1A"/>
+                </a:solidFill>
+              </a:defRPr>
+            </a:pPr>
+            <a:r>
+              <a:t>3-class 확률</a:t>
+            </a:r>
+          </a:p>
+          <a:p>
+            <a:pPr algn="ctr">
+              <a:defRPr sz="850">
+                <a:solidFill>
+                  <a:srgbClr val="7A0000"/>
+                </a:solidFill>
+              </a:defRPr>
+            </a:pPr>
+            <a:r>
+              <a:t>(3,)/윈도우</a:t>
+            </a:r>
+          </a:p>
+        </p:txBody>
+      </p:sp>
+      <p:sp>
+        <p:nvSpPr>
+          <p:cNvPr id="14" name="TextBox 13"/>
+          <p:cNvSpPr txBox="1"/>
+          <p:nvPr/>
+        </p:nvSpPr>
+        <p:spPr>
+          <a:xfrm>
+            <a:off x="7040880" y="2578608"/>
+            <a:ext cx="1600200" cy="411480"/>
+          </a:xfrm>
+          <a:prstGeom prst="rect">
+            <a:avLst/>
+          </a:prstGeom>
+          <a:noFill/>
+        </p:spPr>
+        <p:txBody>
+          <a:bodyPr wrap="square">
+            <a:spAutoFit/>
+          </a:bodyPr>
+          <a:lstStyle/>
+          <a:p>
+            <a:pPr algn="ctr">
+              <a:defRPr sz="800">
+                <a:solidFill>
+                  <a:srgbClr val="444444"/>
+                </a:solidFill>
+              </a:defRPr>
+            </a:pPr>
+            <a:r>
+              <a:t>스핀 0/1/2개 확률</a:t>
+            </a:r>
+          </a:p>
+        </p:txBody>
+      </p:sp>
+      <p:cxnSp>
+        <p:nvCxnSpPr>
+          <p:cNvPr id="15" name="Connector 14"/>
+          <p:cNvCxnSpPr/>
+          <p:nvPr/>
+        </p:nvCxnSpPr>
+        <p:spPr>
+          <a:xfrm>
+            <a:off x="8613648" y="2125980"/>
+            <a:ext cx="237744" cy="0"/>
+          </a:xfrm>
+          <a:prstGeom prst="line">
+            <a:avLst/>
+          </a:prstGeom>
+          <a:ln w="28575">
+            <a:solidFill>
+              <a:srgbClr val="404040"/>
+            </a:solidFill>
+            <a:tailEnd type="triangle" w="med" len="med"/>
+          </a:ln>
+        </p:spPr>
+        <p:style>
+          <a:lnRef idx="2">
+            <a:schemeClr val="accent1"/>
+          </a:lnRef>
+          <a:fillRef idx="0">
+            <a:schemeClr val="accent1"/>
+          </a:fillRef>
+          <a:effectRef idx="1">
+            <a:schemeClr val="accent1"/>
+          </a:effectRef>
+          <a:fontRef idx="minor">
+            <a:schemeClr val="tx1"/>
+          </a:fontRef>
+        </p:style>
+      </p:cxnSp>
+      <p:sp>
+        <p:nvSpPr>
+          <p:cNvPr id="16" name="Rounded Rectangle 15"/>
+          <p:cNvSpPr/>
+          <p:nvPr/>
+        </p:nvSpPr>
+        <p:spPr>
+          <a:xfrm>
+            <a:off x="8869680" y="1691640"/>
+            <a:ext cx="1371600" cy="868680"/>
+          </a:xfrm>
+          <a:prstGeom prst="roundRect">
+            <a:avLst/>
+          </a:prstGeom>
+          <a:solidFill>
+            <a:srgbClr val="FDEBD0"/>
+          </a:solidFill>
+          <a:ln>
+            <a:solidFill>
+              <a:srgbClr val="666666"/>
+            </a:solidFill>
+          </a:ln>
+          <a:effectLst/>
+        </p:spPr>
+        <p:style>
+          <a:lnRef idx="1">
+            <a:schemeClr val="accent1"/>
+          </a:lnRef>
+          <a:fillRef idx="3">
+            <a:schemeClr val="accent1"/>
+          </a:fillRef>
+          <a:effectRef idx="2">
+            <a:schemeClr val="accent1"/>
+          </a:effectRef>
+          <a:fontRef idx="minor">
+            <a:schemeClr val="lt1"/>
+          </a:fontRef>
+        </p:style>
+        <p:txBody>
+          <a:bodyPr rtlCol="0" anchor="ctr" wrap="square"/>
+          <a:lstStyle/>
+          <a:p>
+            <a:pPr algn="ctr">
+              <a:defRPr sz="1100" b="1">
+                <a:solidFill>
+                  <a:srgbClr val="1A1A1A"/>
+                </a:solidFill>
+              </a:defRPr>
+            </a:pPr>
+            <a:r>
+              <a:t>피크 검출</a:t>
+            </a:r>
+          </a:p>
+          <a:p>
+            <a:pPr algn="ctr">
+              <a:defRPr sz="850">
+                <a:solidFill>
+                  <a:srgbClr val="7A0000"/>
+                </a:solidFill>
+              </a:defRPr>
+            </a:pPr>
+            <a:r>
+              <a:t>A 영역만</a:t>
+            </a:r>
+          </a:p>
+        </p:txBody>
+      </p:sp>
+      <p:sp>
+        <p:nvSpPr>
+          <p:cNvPr id="17" name="TextBox 16"/>
+          <p:cNvSpPr txBox="1"/>
+          <p:nvPr/>
+        </p:nvSpPr>
+        <p:spPr>
+          <a:xfrm>
+            <a:off x="8823959" y="2578608"/>
+            <a:ext cx="1463040" cy="411480"/>
+          </a:xfrm>
+          <a:prstGeom prst="rect">
+            <a:avLst/>
+          </a:prstGeom>
+          <a:noFill/>
+        </p:spPr>
+        <p:txBody>
+          <a:bodyPr wrap="square">
+            <a:spAutoFit/>
+          </a:bodyPr>
+          <a:lstStyle/>
+          <a:p>
+            <a:pPr algn="ctr">
+              <a:defRPr sz="800">
+                <a:solidFill>
+                  <a:srgbClr val="444444"/>
+                </a:solidFill>
+              </a:defRPr>
+            </a:pPr>
+            <a:r>
+              <a:t>개수·B값 미해결</a:t>
+            </a:r>
+          </a:p>
+        </p:txBody>
+      </p:sp>
+      <p:sp>
+        <p:nvSpPr>
+          <p:cNvPr id="18" name="TextBox 17"/>
+          <p:cNvSpPr txBox="1"/>
+          <p:nvPr/>
+        </p:nvSpPr>
+        <p:spPr>
+          <a:xfrm>
+            <a:off x="137160" y="4069079"/>
+            <a:ext cx="1600200" cy="914400"/>
+          </a:xfrm>
+          <a:prstGeom prst="rect">
+            <a:avLst/>
+          </a:prstGeom>
+          <a:noFill/>
+        </p:spPr>
+        <p:txBody>
+          <a:bodyPr wrap="square">
+            <a:spAutoFit/>
+          </a:bodyPr>
+          <a:lstStyle/>
+          <a:p>
+            <a:pPr>
+              <a:defRPr sz="1300" b="1">
+                <a:solidFill>
+                  <a:srgbClr val="CC0000"/>
+                </a:solidFill>
+              </a:defRPr>
+            </a:pPr>
+            <a:r>
+              <a:t>우리 방법</a:t>
+            </a:r>
+          </a:p>
+          <a:p>
+            <a:r>
+              <a:t>(하이브리드 v2)</a:t>
+            </a:r>
+          </a:p>
+        </p:txBody>
+      </p:sp>
+      <p:sp>
+        <p:nvSpPr>
+          <p:cNvPr id="19" name="Rounded Rectangle 18"/>
+          <p:cNvSpPr/>
+          <p:nvPr/>
+        </p:nvSpPr>
+        <p:spPr>
+          <a:xfrm>
+            <a:off x="1828800" y="3977639"/>
+            <a:ext cx="1188720" cy="868680"/>
+          </a:xfrm>
+          <a:prstGeom prst="roundRect">
+            <a:avLst/>
+          </a:prstGeom>
+          <a:solidFill>
+            <a:srgbClr val="E8E8E8"/>
+          </a:solidFill>
+          <a:ln>
+            <a:solidFill>
+              <a:srgbClr val="666666"/>
+            </a:solidFill>
+          </a:ln>
+          <a:effectLst/>
+        </p:spPr>
+        <p:style>
+          <a:lnRef idx="1">
+            <a:schemeClr val="accent1"/>
+          </a:lnRef>
+          <a:fillRef idx="3">
+            <a:schemeClr val="accent1"/>
+          </a:fillRef>
+          <a:effectRef idx="2">
+            <a:schemeClr val="accent1"/>
+          </a:effectRef>
+          <a:fontRef idx="minor">
+            <a:schemeClr val="lt1"/>
+          </a:fontRef>
+        </p:style>
+        <p:txBody>
+          <a:bodyPr rtlCol="0" anchor="ctr" wrap="square"/>
+          <a:lstStyle/>
+          <a:p>
+            <a:pPr algn="ctr">
+              <a:defRPr sz="1100" b="1">
+                <a:solidFill>
+                  <a:srgbClr val="1A1A1A"/>
+                </a:solidFill>
+              </a:defRPr>
+            </a:pPr>
+            <a:r>
+              <a:t>신호 3채널</a:t>
+            </a:r>
+          </a:p>
+          <a:p>
+            <a:pPr algn="ctr">
+              <a:defRPr sz="850">
+                <a:solidFill>
+                  <a:srgbClr val="7A0000"/>
+                </a:solidFill>
+              </a:defRPr>
+            </a:pPr>
+            <a:r>
+              <a:t>(3, 700)</a:t>
+            </a:r>
+          </a:p>
+        </p:txBody>
+      </p:sp>
+      <p:sp>
+        <p:nvSpPr>
+          <p:cNvPr id="20" name="TextBox 19"/>
+          <p:cNvSpPr txBox="1"/>
+          <p:nvPr/>
+        </p:nvSpPr>
+        <p:spPr>
+          <a:xfrm>
+            <a:off x="1783080" y="4864607"/>
+            <a:ext cx="1280160" cy="411480"/>
+          </a:xfrm>
+          <a:prstGeom prst="rect">
+            <a:avLst/>
+          </a:prstGeom>
+          <a:noFill/>
+        </p:spPr>
+        <p:txBody>
+          <a:bodyPr wrap="square">
+            <a:spAutoFit/>
+          </a:bodyPr>
+          <a:lstStyle/>
+          <a:p>
+            <a:pPr algn="ctr">
+              <a:defRPr sz="800">
+                <a:solidFill>
+                  <a:srgbClr val="444444"/>
+                </a:solidFill>
+              </a:defRPr>
+            </a:pPr>
+            <a:r>
+              <a:t>N=8/16/20 함께</a:t>
+            </a:r>
+          </a:p>
+        </p:txBody>
+      </p:sp>
+      <p:cxnSp>
+        <p:nvCxnSpPr>
+          <p:cNvPr id="21" name="Connector 20"/>
+          <p:cNvCxnSpPr/>
+          <p:nvPr/>
+        </p:nvCxnSpPr>
+        <p:spPr>
+          <a:xfrm>
+            <a:off x="3035808" y="4411979"/>
+            <a:ext cx="237743" cy="0"/>
+          </a:xfrm>
+          <a:prstGeom prst="line">
+            <a:avLst/>
+          </a:prstGeom>
+          <a:ln w="28575">
+            <a:solidFill>
+              <a:srgbClr val="404040"/>
+            </a:solidFill>
+            <a:tailEnd type="triangle" w="med" len="med"/>
+          </a:ln>
+        </p:spPr>
+        <p:style>
+          <a:lnRef idx="2">
+            <a:schemeClr val="accent1"/>
+          </a:lnRef>
+          <a:fillRef idx="0">
+            <a:schemeClr val="accent1"/>
+          </a:fillRef>
+          <a:effectRef idx="1">
+            <a:schemeClr val="accent1"/>
+          </a:effectRef>
+          <a:fontRef idx="minor">
+            <a:schemeClr val="tx1"/>
+          </a:fontRef>
+        </p:style>
+      </p:cxnSp>
+      <p:sp>
+        <p:nvSpPr>
+          <p:cNvPr id="22" name="Rounded Rectangle 21"/>
+          <p:cNvSpPr/>
+          <p:nvPr/>
+        </p:nvSpPr>
+        <p:spPr>
+          <a:xfrm>
+            <a:off x="3291840" y="3977639"/>
+            <a:ext cx="1463040" cy="868680"/>
+          </a:xfrm>
+          <a:prstGeom prst="roundRect">
+            <a:avLst/>
+          </a:prstGeom>
+          <a:solidFill>
+            <a:srgbClr val="DBE9F8"/>
+          </a:solidFill>
+          <a:ln>
+            <a:solidFill>
+              <a:srgbClr val="666666"/>
+            </a:solidFill>
+          </a:ln>
+          <a:effectLst/>
+        </p:spPr>
+        <p:style>
+          <a:lnRef idx="1">
+            <a:schemeClr val="accent1"/>
+          </a:lnRef>
+          <a:fillRef idx="3">
+            <a:schemeClr val="accent1"/>
+          </a:fillRef>
+          <a:effectRef idx="2">
+            <a:schemeClr val="accent1"/>
+          </a:effectRef>
+          <a:fontRef idx="minor">
+            <a:schemeClr val="lt1"/>
+          </a:fontRef>
+        </p:style>
+        <p:txBody>
+          <a:bodyPr rtlCol="0" anchor="ctr" wrap="square"/>
+          <a:lstStyle/>
+          <a:p>
+            <a:pPr algn="ctr">
+              <a:defRPr sz="1100" b="1">
+                <a:solidFill>
+                  <a:srgbClr val="1A1A1A"/>
+                </a:solidFill>
+              </a:defRPr>
+            </a:pPr>
+            <a:r>
+              <a:t>61윈도우 접기</a:t>
+            </a:r>
+          </a:p>
+          <a:p>
+            <a:pPr algn="ctr">
+              <a:defRPr sz="850">
+                <a:solidFill>
+                  <a:srgbClr val="7A0000"/>
+                </a:solidFill>
+              </a:defRPr>
+            </a:pPr>
+            <a:r>
+              <a:t>토큰(61,3,13,53)</a:t>
+            </a:r>
+          </a:p>
+        </p:txBody>
+      </p:sp>
+      <p:sp>
+        <p:nvSpPr>
+          <p:cNvPr id="23" name="TextBox 22"/>
+          <p:cNvSpPr txBox="1"/>
+          <p:nvPr/>
+        </p:nvSpPr>
+        <p:spPr>
+          <a:xfrm>
+            <a:off x="3246120" y="4864607"/>
+            <a:ext cx="1554480" cy="411480"/>
+          </a:xfrm>
+          <a:prstGeom prst="rect">
+            <a:avLst/>
+          </a:prstGeom>
+          <a:noFill/>
+        </p:spPr>
+        <p:txBody>
+          <a:bodyPr wrap="square">
+            <a:spAutoFit/>
+          </a:bodyPr>
+          <a:lstStyle/>
+          <a:p>
+            <a:pPr algn="ctr">
+              <a:defRPr sz="800">
+                <a:solidFill>
+                  <a:srgbClr val="444444"/>
+                </a:solidFill>
+              </a:defRPr>
+            </a:pPr>
+            <a:r>
+              <a:t>모든 주기 동시에</a:t>
+            </a:r>
+          </a:p>
+        </p:txBody>
+      </p:sp>
+      <p:cxnSp>
+        <p:nvCxnSpPr>
+          <p:cNvPr id="24" name="Connector 23"/>
+          <p:cNvCxnSpPr/>
+          <p:nvPr/>
+        </p:nvCxnSpPr>
+        <p:spPr>
+          <a:xfrm>
+            <a:off x="4773168" y="4411979"/>
+            <a:ext cx="237744" cy="0"/>
+          </a:xfrm>
+          <a:prstGeom prst="line">
+            <a:avLst/>
+          </a:prstGeom>
+          <a:ln w="28575">
+            <a:solidFill>
+              <a:srgbClr val="404040"/>
+            </a:solidFill>
+            <a:tailEnd type="triangle" w="med" len="med"/>
+          </a:ln>
+        </p:spPr>
+        <p:style>
+          <a:lnRef idx="2">
+            <a:schemeClr val="accent1"/>
+          </a:lnRef>
+          <a:fillRef idx="0">
+            <a:schemeClr val="accent1"/>
+          </a:fillRef>
+          <a:effectRef idx="1">
+            <a:schemeClr val="accent1"/>
+          </a:effectRef>
+          <a:fontRef idx="minor">
+            <a:schemeClr val="tx1"/>
+          </a:fontRef>
+        </p:style>
+      </p:cxnSp>
+      <p:sp>
+        <p:nvSpPr>
+          <p:cNvPr id="25" name="Rounded Rectangle 24"/>
+          <p:cNvSpPr/>
+          <p:nvPr/>
+        </p:nvSpPr>
+        <p:spPr>
+          <a:xfrm>
+            <a:off x="5029200" y="3977639"/>
+            <a:ext cx="1371600" cy="868680"/>
+          </a:xfrm>
+          <a:prstGeom prst="roundRect">
+            <a:avLst/>
+          </a:prstGeom>
+          <a:solidFill>
+            <a:srgbClr val="DFF2DF"/>
+          </a:solidFill>
+          <a:ln>
+            <a:solidFill>
+              <a:srgbClr val="666666"/>
+            </a:solidFill>
+          </a:ln>
+          <a:effectLst/>
+        </p:spPr>
+        <p:style>
+          <a:lnRef idx="1">
+            <a:schemeClr val="accent1"/>
+          </a:lnRef>
+          <a:fillRef idx="3">
+            <a:schemeClr val="accent1"/>
+          </a:fillRef>
+          <a:effectRef idx="2">
+            <a:schemeClr val="accent1"/>
+          </a:effectRef>
+          <a:fontRef idx="minor">
+            <a:schemeClr val="lt1"/>
+          </a:fontRef>
+        </p:style>
+        <p:txBody>
+          <a:bodyPr rtlCol="0" anchor="ctr" wrap="square"/>
+          <a:lstStyle/>
+          <a:p>
+            <a:pPr algn="ctr">
+              <a:defRPr sz="1100" b="1">
+                <a:solidFill>
+                  <a:srgbClr val="1A1A1A"/>
+                </a:solidFill>
+              </a:defRPr>
+            </a:pPr>
+            <a:r>
+              <a:t>어텐션 ×4</a:t>
+            </a:r>
+          </a:p>
+          <a:p>
+            <a:pPr algn="ctr">
+              <a:defRPr sz="850">
+                <a:solidFill>
+                  <a:srgbClr val="7A0000"/>
+                </a:solidFill>
+              </a:defRPr>
+            </a:pPr>
+            <a:r>
+              <a:t>윈도우 간 회의</a:t>
+            </a:r>
+          </a:p>
+        </p:txBody>
+      </p:sp>
+      <p:sp>
+        <p:nvSpPr>
+          <p:cNvPr id="26" name="TextBox 25"/>
+          <p:cNvSpPr txBox="1"/>
+          <p:nvPr/>
+        </p:nvSpPr>
+        <p:spPr>
+          <a:xfrm>
+            <a:off x="4983480" y="4864607"/>
+            <a:ext cx="1463040" cy="411480"/>
+          </a:xfrm>
+          <a:prstGeom prst="rect">
+            <a:avLst/>
+          </a:prstGeom>
+          <a:noFill/>
+        </p:spPr>
+        <p:txBody>
+          <a:bodyPr wrap="square">
+            <a:spAutoFit/>
+          </a:bodyPr>
+          <a:lstStyle/>
+          <a:p>
+            <a:pPr algn="ctr">
+              <a:defRPr sz="800">
+                <a:solidFill>
+                  <a:srgbClr val="444444"/>
+                </a:solidFill>
+              </a:defRPr>
+            </a:pPr>
+            <a:r>
+              <a:t>진짜 스핀만 통과 · 오탐 0</a:t>
+            </a:r>
+          </a:p>
+        </p:txBody>
+      </p:sp>
+      <p:cxnSp>
+        <p:nvCxnSpPr>
+          <p:cNvPr id="27" name="Connector 26"/>
+          <p:cNvCxnSpPr/>
+          <p:nvPr/>
+        </p:nvCxnSpPr>
+        <p:spPr>
+          <a:xfrm>
+            <a:off x="6419088" y="4411979"/>
+            <a:ext cx="237744" cy="0"/>
+          </a:xfrm>
+          <a:prstGeom prst="line">
+            <a:avLst/>
+          </a:prstGeom>
+          <a:ln w="28575">
+            <a:solidFill>
+              <a:srgbClr val="404040"/>
+            </a:solidFill>
+            <a:tailEnd type="triangle" w="med" len="med"/>
+          </a:ln>
+        </p:spPr>
+        <p:style>
+          <a:lnRef idx="2">
+            <a:schemeClr val="accent1"/>
+          </a:lnRef>
+          <a:fillRef idx="0">
+            <a:schemeClr val="accent1"/>
+          </a:fillRef>
+          <a:effectRef idx="1">
+            <a:schemeClr val="accent1"/>
+          </a:effectRef>
+          <a:fontRef idx="minor">
+            <a:schemeClr val="tx1"/>
+          </a:fontRef>
+        </p:style>
+      </p:cxnSp>
+      <p:sp>
+        <p:nvSpPr>
+          <p:cNvPr id="28" name="Rounded Rectangle 27"/>
+          <p:cNvSpPr/>
+          <p:nvPr/>
+        </p:nvSpPr>
+        <p:spPr>
+          <a:xfrm>
+            <a:off x="6675120" y="3977639"/>
+            <a:ext cx="1371600" cy="868680"/>
+          </a:xfrm>
+          <a:prstGeom prst="roundRect">
+            <a:avLst/>
+          </a:prstGeom>
+          <a:solidFill>
+            <a:srgbClr val="FDEBD0"/>
+          </a:solidFill>
+          <a:ln>
+            <a:solidFill>
+              <a:srgbClr val="666666"/>
+            </a:solidFill>
+          </a:ln>
+          <a:effectLst/>
+        </p:spPr>
+        <p:style>
+          <a:lnRef idx="1">
+            <a:schemeClr val="accent1"/>
+          </a:lnRef>
+          <a:fillRef idx="3">
+            <a:schemeClr val="accent1"/>
+          </a:fillRef>
+          <a:effectRef idx="2">
+            <a:schemeClr val="accent1"/>
+          </a:effectRef>
+          <a:fontRef idx="minor">
+            <a:schemeClr val="lt1"/>
+          </a:fontRef>
+        </p:style>
+        <p:txBody>
+          <a:bodyPr rtlCol="0" anchor="ctr" wrap="square"/>
+          <a:lstStyle/>
+          <a:p>
+            <a:pPr algn="ctr">
+              <a:defRPr sz="1100" b="1">
+                <a:solidFill>
+                  <a:srgbClr val="1A1A1A"/>
+                </a:solidFill>
+              </a:defRPr>
+            </a:pPr>
+            <a:r>
+              <a:t>P(spin) → 영역</a:t>
+            </a:r>
+          </a:p>
+          <a:p>
+            <a:pPr algn="ctr">
+              <a:defRPr sz="850">
+                <a:solidFill>
+                  <a:srgbClr val="7A0000"/>
+                </a:solidFill>
+              </a:defRPr>
+            </a:pPr>
+            <a:r>
+              <a:t>후보 구간</a:t>
+            </a:r>
+          </a:p>
+        </p:txBody>
+      </p:sp>
+      <p:sp>
+        <p:nvSpPr>
+          <p:cNvPr id="29" name="TextBox 28"/>
+          <p:cNvSpPr txBox="1"/>
+          <p:nvPr/>
+        </p:nvSpPr>
+        <p:spPr>
+          <a:xfrm>
+            <a:off x="6629400" y="4864607"/>
+            <a:ext cx="1463040" cy="411480"/>
+          </a:xfrm>
+          <a:prstGeom prst="rect">
+            <a:avLst/>
+          </a:prstGeom>
+          <a:noFill/>
+        </p:spPr>
+        <p:txBody>
+          <a:bodyPr wrap="square">
+            <a:spAutoFit/>
+          </a:bodyPr>
+          <a:lstStyle/>
+          <a:p>
+            <a:pPr algn="ctr">
+              <a:defRPr sz="800">
+                <a:solidFill>
+                  <a:srgbClr val="444444"/>
+                </a:solidFill>
+              </a:defRPr>
+            </a:pPr>
+            <a:r>
+              <a:t>어디를 팔지 확정</a:t>
+            </a:r>
+          </a:p>
+        </p:txBody>
+      </p:sp>
+      <p:cxnSp>
+        <p:nvCxnSpPr>
+          <p:cNvPr id="30" name="Connector 29"/>
+          <p:cNvCxnSpPr/>
+          <p:nvPr/>
+        </p:nvCxnSpPr>
+        <p:spPr>
+          <a:xfrm>
+            <a:off x="8065008" y="4411979"/>
+            <a:ext cx="237744" cy="0"/>
+          </a:xfrm>
+          <a:prstGeom prst="line">
+            <a:avLst/>
+          </a:prstGeom>
+          <a:ln w="28575">
+            <a:solidFill>
+              <a:srgbClr val="404040"/>
+            </a:solidFill>
+            <a:tailEnd type="triangle" w="med" len="med"/>
+          </a:ln>
+        </p:spPr>
+        <p:style>
+          <a:lnRef idx="2">
+            <a:schemeClr val="accent1"/>
+          </a:lnRef>
+          <a:fillRef idx="0">
+            <a:schemeClr val="accent1"/>
+          </a:fillRef>
+          <a:effectRef idx="1">
+            <a:schemeClr val="accent1"/>
+          </a:effectRef>
+          <a:fontRef idx="minor">
+            <a:schemeClr val="tx1"/>
+          </a:fontRef>
+        </p:style>
+      </p:cxnSp>
+      <p:sp>
+        <p:nvSpPr>
+          <p:cNvPr id="31" name="Rounded Rectangle 30"/>
+          <p:cNvSpPr/>
+          <p:nvPr/>
+        </p:nvSpPr>
+        <p:spPr>
+          <a:xfrm>
+            <a:off x="8321040" y="3977639"/>
+            <a:ext cx="1600200" cy="868680"/>
+          </a:xfrm>
+          <a:prstGeom prst="roundRect">
+            <a:avLst/>
+          </a:prstGeom>
+          <a:solidFill>
+            <a:srgbClr val="DFF2DF"/>
+          </a:solidFill>
+          <a:ln>
+            <a:solidFill>
+              <a:srgbClr val="666666"/>
+            </a:solidFill>
+          </a:ln>
+          <a:effectLst/>
+        </p:spPr>
+        <p:style>
+          <a:lnRef idx="1">
+            <a:schemeClr val="accent1"/>
+          </a:lnRef>
+          <a:fillRef idx="3">
+            <a:schemeClr val="accent1"/>
+          </a:fillRef>
+          <a:effectRef idx="2">
+            <a:schemeClr val="accent1"/>
+          </a:effectRef>
+          <a:fontRef idx="minor">
+            <a:schemeClr val="lt1"/>
+          </a:fontRef>
+        </p:style>
+        <p:txBody>
+          <a:bodyPr rtlCol="0" anchor="ctr" wrap="square"/>
+          <a:lstStyle/>
+          <a:p>
+            <a:pPr algn="ctr">
+              <a:defRPr sz="1100" b="1">
+                <a:solidFill>
+                  <a:srgbClr val="1A1A1A"/>
+                </a:solidFill>
+              </a:defRPr>
+            </a:pPr>
+            <a:r>
+              <a:t>영역 제약</a:t>
+            </a:r>
+          </a:p>
+          <a:p>
+            <a:r>
+              <a:t>RJMCMC + BIC</a:t>
+            </a:r>
+          </a:p>
+          <a:p>
+            <a:pPr algn="ctr">
+              <a:defRPr sz="850">
+                <a:solidFill>
+                  <a:srgbClr val="7A0000"/>
+                </a:solidFill>
+              </a:defRPr>
+            </a:pPr>
+            <a:r>
+              <a:t>물리 공식 피팅</a:t>
+            </a:r>
+          </a:p>
+        </p:txBody>
+      </p:sp>
+      <p:sp>
+        <p:nvSpPr>
+          <p:cNvPr id="32" name="TextBox 31"/>
+          <p:cNvSpPr txBox="1"/>
+          <p:nvPr/>
+        </p:nvSpPr>
+        <p:spPr>
+          <a:xfrm>
+            <a:off x="8275319" y="4864607"/>
+            <a:ext cx="1691640" cy="411480"/>
+          </a:xfrm>
+          <a:prstGeom prst="rect">
+            <a:avLst/>
+          </a:prstGeom>
+          <a:noFill/>
+        </p:spPr>
+        <p:txBody>
+          <a:bodyPr wrap="square">
+            <a:spAutoFit/>
+          </a:bodyPr>
+          <a:lstStyle/>
+          <a:p>
+            <a:pPr algn="ctr">
+              <a:defRPr sz="800">
+                <a:solidFill>
+                  <a:srgbClr val="444444"/>
+                </a:solidFill>
+              </a:defRPr>
+            </a:pPr>
+            <a:r>
+              <a:t>몇 개인지 통계로 결정</a:t>
+            </a:r>
+          </a:p>
+        </p:txBody>
+      </p:sp>
+      <p:cxnSp>
+        <p:nvCxnSpPr>
+          <p:cNvPr id="33" name="Connector 32"/>
+          <p:cNvCxnSpPr/>
+          <p:nvPr/>
+        </p:nvCxnSpPr>
+        <p:spPr>
+          <a:xfrm>
+            <a:off x="9939528" y="4411979"/>
+            <a:ext cx="237744" cy="0"/>
+          </a:xfrm>
+          <a:prstGeom prst="line">
+            <a:avLst/>
+          </a:prstGeom>
+          <a:ln w="28575">
+            <a:solidFill>
+              <a:srgbClr val="404040"/>
+            </a:solidFill>
+            <a:tailEnd type="triangle" w="med" len="med"/>
+          </a:ln>
+        </p:spPr>
+        <p:style>
+          <a:lnRef idx="2">
+            <a:schemeClr val="accent1"/>
+          </a:lnRef>
+          <a:fillRef idx="0">
+            <a:schemeClr val="accent1"/>
+          </a:fillRef>
+          <a:effectRef idx="1">
+            <a:schemeClr val="accent1"/>
+          </a:effectRef>
+          <a:fontRef idx="minor">
+            <a:schemeClr val="tx1"/>
+          </a:fontRef>
+        </p:style>
+      </p:cxnSp>
+      <p:sp>
+        <p:nvSpPr>
+          <p:cNvPr id="34" name="Rounded Rectangle 33"/>
+          <p:cNvSpPr/>
+          <p:nvPr/>
+        </p:nvSpPr>
+        <p:spPr>
+          <a:xfrm>
+            <a:off x="10195559" y="3977639"/>
+            <a:ext cx="1417320" cy="868680"/>
+          </a:xfrm>
+          <a:prstGeom prst="roundRect">
+            <a:avLst/>
+          </a:prstGeom>
+          <a:solidFill>
+            <a:srgbClr val="FDEBD0"/>
+          </a:solidFill>
+          <a:ln>
+            <a:solidFill>
+              <a:srgbClr val="666666"/>
+            </a:solidFill>
+          </a:ln>
+          <a:effectLst/>
+        </p:spPr>
+        <p:style>
+          <a:lnRef idx="1">
+            <a:schemeClr val="accent1"/>
+          </a:lnRef>
+          <a:fillRef idx="3">
+            <a:schemeClr val="accent1"/>
+          </a:fillRef>
+          <a:effectRef idx="2">
+            <a:schemeClr val="accent1"/>
+          </a:effectRef>
+          <a:fontRef idx="minor">
+            <a:schemeClr val="lt1"/>
+          </a:fontRef>
+        </p:style>
+        <p:txBody>
+          <a:bodyPr rtlCol="0" anchor="ctr" wrap="square"/>
+          <a:lstStyle/>
+          <a:p>
+            <a:pPr algn="ctr">
+              <a:defRPr sz="1100" b="1">
+                <a:solidFill>
+                  <a:srgbClr val="1A1A1A"/>
+                </a:solidFill>
+              </a:defRPr>
+            </a:pPr>
+            <a:r>
+              <a:t>스핀 목록</a:t>
+            </a:r>
+          </a:p>
+          <a:p>
+            <a:pPr algn="ctr">
+              <a:defRPr sz="850">
+                <a:solidFill>
+                  <a:srgbClr val="7A0000"/>
+                </a:solidFill>
+              </a:defRPr>
+            </a:pPr>
+            <a:r>
+              <a:t>{(A∥,A⊥)}×k*</a:t>
+            </a:r>
+          </a:p>
+        </p:txBody>
+      </p:sp>
+      <p:sp>
+        <p:nvSpPr>
+          <p:cNvPr id="35" name="TextBox 34"/>
+          <p:cNvSpPr txBox="1"/>
+          <p:nvPr/>
+        </p:nvSpPr>
+        <p:spPr>
+          <a:xfrm>
+            <a:off x="10149839" y="4864607"/>
+            <a:ext cx="1508760" cy="411480"/>
+          </a:xfrm>
+          <a:prstGeom prst="rect">
+            <a:avLst/>
+          </a:prstGeom>
+          <a:noFill/>
+        </p:spPr>
+        <p:txBody>
+          <a:bodyPr wrap="square">
+            <a:spAutoFit/>
+          </a:bodyPr>
+          <a:lstStyle/>
+          <a:p>
+            <a:pPr algn="ctr">
+              <a:defRPr sz="800">
+                <a:solidFill>
+                  <a:srgbClr val="444444"/>
+                </a:solidFill>
+              </a:defRPr>
+            </a:pPr>
+            <a:r>
+              <a:t>NV1 14개 · CI 포함</a:t>
+            </a:r>
+          </a:p>
+        </p:txBody>
+      </p:sp>
+      <p:sp>
+        <p:nvSpPr>
+          <p:cNvPr id="36" name="TextBox 35"/>
+          <p:cNvSpPr txBox="1"/>
+          <p:nvPr/>
+        </p:nvSpPr>
+        <p:spPr>
+          <a:xfrm>
+            <a:off x="1828800" y="3063240"/>
+            <a:ext cx="10058400" cy="502920"/>
+          </a:xfrm>
+          <a:prstGeom prst="rect">
+            <a:avLst/>
+          </a:prstGeom>
+          <a:noFill/>
+        </p:spPr>
+        <p:txBody>
+          <a:bodyPr wrap="none">
+            <a:spAutoFit/>
+          </a:bodyPr>
+          <a:lstStyle/>
+          <a:p>
+            <a:pPr>
+              <a:defRPr sz="1150" b="1">
+                <a:solidFill>
+                  <a:srgbClr val="1155CC"/>
+                </a:solidFill>
+              </a:defRPr>
+            </a:pPr>
+            <a:r>
+              <a:t>↕ 같은 '주기 접기'에서 출발하지만 — 2021은 여기서 끝(고립 판정), 우리는 접은 61개를 토큰으로 묶어 회의시키고, 그 결과 영역 안에서만 물리 피팅으로 열거</a:t>
+            </a:r>
+          </a:p>
+        </p:txBody>
+      </p:sp>
+      <p:sp>
+        <p:nvSpPr>
+          <p:cNvPr id="37" name="TextBox 36"/>
+          <p:cNvSpPr txBox="1"/>
+          <p:nvPr/>
+        </p:nvSpPr>
+        <p:spPr>
+          <a:xfrm>
+            <a:off x="365760" y="6172200"/>
+            <a:ext cx="11430000" cy="548640"/>
+          </a:xfrm>
+          <a:prstGeom prst="rect">
+            <a:avLst/>
+          </a:prstGeom>
+          <a:noFill/>
+        </p:spPr>
+        <p:txBody>
+          <a:bodyPr wrap="square">
+            <a:spAutoFit/>
+          </a:bodyPr>
+          <a:lstStyle/>
+          <a:p>
+            <a:pPr>
+              <a:defRPr sz="1150"/>
+            </a:pPr>
+            <a:r>
+              <a:t>• 출력의 격 차이 — 2021: A 위치 후보(영역)까지 · 우리: 개수(k*)·결합강도(A⊥)·오차막대(CI)까지 완결    • 검증 격 차이 — 실측 50-스핀 채점 F1 0.35~0.38 vs 0.57~0.84</a:t>
+            </a:r>
+          </a:p>
+        </p:txBody>
+      </p:sp>
+    </p:spTree>
+  </p:cSld>
+  <p:clrMapOvr>
+    <a:masterClrMapping/>
+  </p:clrMapOvr>
+</p:sld>
+</file>
+
+<file path=ppt/slides/slide4.xml><?xml version="1.0" encoding="utf-8"?>
+<p:sld xmlns:a="http://schemas.openxmlformats.org/drawingml/2006/main" xmlns:p="http://schemas.openxmlformats.org/presentationml/2006/main" xmlns:r="http://schemas.openxmlformats.org/officeDocument/2006/relationships">
+  <p:cSld>
+    <p:spTree>
+      <p:nvGrpSpPr>
+        <p:cNvPr id="1" name=""/>
+        <p:cNvGrpSpPr/>
+        <p:nvPr/>
+      </p:nvGrpSpPr>
+      <p:grpSpPr/>
+      <p:sp>
+        <p:nvSpPr>
+          <p:cNvPr id="2" name="TextBox 1"/>
+          <p:cNvSpPr txBox="1"/>
+          <p:nvPr/>
+        </p:nvSpPr>
+        <p:spPr>
+          <a:xfrm>
+            <a:off x="365760" y="109728"/>
+            <a:ext cx="11430000" cy="914400"/>
+          </a:xfrm>
+          <a:prstGeom prst="rect">
+            <a:avLst/>
+          </a:prstGeom>
+          <a:noFill/>
+        </p:spPr>
+        <p:txBody>
+          <a:bodyPr wrap="none">
+            <a:spAutoFit/>
+          </a:bodyPr>
+          <a:lstStyle/>
+          <a:p>
+            <a:pPr>
+              <a:defRPr sz="2600" b="1"/>
+            </a:pPr>
+            <a:r>
               <a:t>요약 ②: 공개 실측 50-스핀 배스로 검증</a:t>
             </a:r>
           </a:p>
@@ -4341,7 +6008,7 @@
 </p:sld>
 </file>
 
-<file path=ppt/slides/slide4.xml><?xml version="1.0" encoding="utf-8"?>
+<file path=ppt/slides/slide5.xml><?xml version="1.0" encoding="utf-8"?>
 <p:sld xmlns:a="http://schemas.openxmlformats.org/drawingml/2006/main" xmlns:p="http://schemas.openxmlformats.org/presentationml/2006/main" xmlns:r="http://schemas.openxmlformats.org/officeDocument/2006/relationships">
   <p:cSld>
     <p:spTree>
@@ -4489,7 +6156,7 @@
 </p:sld>
 </file>
 
-<file path=ppt/slides/slide5.xml><?xml version="1.0" encoding="utf-8"?>
+<file path=ppt/slides/slide6.xml><?xml version="1.0" encoding="utf-8"?>
 <p:sld xmlns:a="http://schemas.openxmlformats.org/drawingml/2006/main" xmlns:p="http://schemas.openxmlformats.org/presentationml/2006/main" xmlns:r="http://schemas.openxmlformats.org/officeDocument/2006/relationships">
   <p:cSld>
     <p:spTree>
@@ -5357,7 +7024,7 @@
 </p:sld>
 </file>
 
-<file path=ppt/slides/slide6.xml><?xml version="1.0" encoding="utf-8"?>
+<file path=ppt/slides/slide7.xml><?xml version="1.0" encoding="utf-8"?>
 <p:sld xmlns:a="http://schemas.openxmlformats.org/drawingml/2006/main" xmlns:p="http://schemas.openxmlformats.org/presentationml/2006/main" xmlns:r="http://schemas.openxmlformats.org/officeDocument/2006/relationships">
   <p:cSld>
     <p:spTree>

</xml_diff>

<commit_message>
Summary slide 1: clarify that the 2021 baseline correctly localized 8-9 of 14 spins (region level) but does not produce a completed spin list
Co-Authored-By: Claude Fable 5 <noreply@anthropic.com>
</commit_message>
<xml_diff>
--- a/results/NV_C13_summary_3slides.pptx
+++ b/results/NV_C13_summary_3slides.pptx
@@ -3140,7 +3140,7 @@
               </a:defRPr>
             </a:pPr>
             <a:r>
-              <a:t>▶ 수동 4개 → 2021 방법은 고확률 영역까지만(개별 분해 불가) → 제안 방법 14개(결합강도+오차막대) — 앵커 전부 회수</a:t>
+              <a:t>▶ 수동 4개 → 2021 방법은 위치 단서 8~9곳(목록 미완성) → 제안 방법 14개 완성(결합강도+오차막대) — 앵커 전부 회수</a:t>
             </a:r>
           </a:p>
         </p:txBody>
@@ -3320,7 +3320,7 @@
                         <a:defRPr sz="1000" b="1"/>
                       </a:pPr>
                       <a:r>
-                        <a:t>스핀 목록이 아닌 '영역'만 출력</a:t>
+                        <a:t>위치 단서까지는 성공 —</a:t>
                       </a:r>
                     </a:p>
                     <a:p>
@@ -3328,7 +3328,7 @@
                         <a:defRPr sz="1000"/>
                       </a:pPr>
                       <a:r>
-                        <a:t>고확률 영역: A∈[−6,+12]</a:t>
+                        <a:t>최종 14개 중 8~9개의 위치를</a:t>
                       </a:r>
                     </a:p>
                     <a:p>
@@ -3336,7 +3336,7 @@
                         <a:defRPr sz="1000"/>
                       </a:pPr>
                       <a:r>
-                        <a:t>(p 0.86~1.00 연속 고원),</a:t>
+                        <a:t>영역/피크 수준으로 지목:</a:t>
                       </a:r>
                     </a:p>
                     <a:p>
@@ -3344,7 +3344,7 @@
                         <a:defRPr sz="1000"/>
                       </a:pPr>
                       <a:r>
-                        <a:t>A∈[+40,+46] + 피크 −34, −20, +22</a:t>
+                        <a:t>[−6,+12](5개 포함), [+40,+46],</a:t>
                       </a:r>
                     </a:p>
                     <a:p>
@@ -3352,7 +3352,7 @@
                         <a:defRPr sz="1000"/>
                       </a:pPr>
                       <a:r>
-                        <a:t>※ 개별 스핀 분해·B값은</a:t>
+                        <a:t>−20, +22, −34</a:t>
                       </a:r>
                     </a:p>
                     <a:p>
@@ -3360,7 +3360,23 @@
                         <a:defRPr sz="1000"/>
                       </a:pPr>
                       <a:r>
-                        <a:t>별도 회귀 단계 필요(미재현)</a:t>
+                        <a:t>※ 단 개수·B값·정확한 A로</a:t>
+                      </a:r>
+                    </a:p>
+                    <a:p>
+                      <a:pPr>
+                        <a:defRPr sz="1000"/>
+                      </a:pPr>
+                      <a:r>
+                        <a:t>완성하는 후반 단계는 미재현</a:t>
+                      </a:r>
+                    </a:p>
+                    <a:p>
+                      <a:pPr>
+                        <a:defRPr sz="1000"/>
+                      </a:pPr>
+                      <a:r>
+                        <a:t>→ 스핀 '목록'은 미산출</a:t>
                       </a:r>
                     </a:p>
                   </a:txBody>

</xml_diff>

<commit_message>
Summary slide 1: explicit 2021 findings list (2 intervals + 3 peaks), plateau wording replaced, per-method verdicts in remarks row
Co-Authored-By: Claude Fable 5 <noreply@anthropic.com>
</commit_message>
<xml_diff>
--- a/results/NV_C13_summary_3slides.pptx
+++ b/results/NV_C13_summary_3slides.pptx
@@ -3140,7 +3140,7 @@
               </a:defRPr>
             </a:pPr>
             <a:r>
-              <a:t>▶ 수동 4개 → 2021 방법은 위치 단서 8~9곳(목록 미완성) → 제안 방법 14개 완성(결합강도+오차막대) — 앵커 전부 회수</a:t>
+              <a:t>▶ 수동 4개 → 2021 방법은 위치 단서 5건(구간 2 + 피크 3, 목록 미완성) → 제안 방법 14개 완성 — 앵커 전부 회수</a:t>
             </a:r>
           </a:p>
         </p:txBody>
@@ -3320,7 +3320,7 @@
                         <a:defRPr sz="1000" b="1"/>
                       </a:pPr>
                       <a:r>
-                        <a:t>위치 단서까지는 성공 —</a:t>
+                        <a:t>위치 단서 5건 (8~9개 스핀 해당)</a:t>
                       </a:r>
                     </a:p>
                     <a:p>
@@ -3328,7 +3328,7 @@
                         <a:defRPr sz="1000"/>
                       </a:pPr>
                       <a:r>
-                        <a:t>최종 14개 중 8~9개의 위치를</a:t>
+                        <a:t>① 구간 A∈[−6, +12]</a:t>
                       </a:r>
                     </a:p>
                     <a:p>
@@ -3336,7 +3336,7 @@
                         <a:defRPr sz="1000"/>
                       </a:pPr>
                       <a:r>
-                        <a:t>영역/피크 수준으로 지목:</a:t>
+                        <a:t>   (연속 고확률 구간, 스핀 5개 포함)</a:t>
                       </a:r>
                     </a:p>
                     <a:p>
@@ -3344,7 +3344,7 @@
                         <a:defRPr sz="1000"/>
                       </a:pPr>
                       <a:r>
-                        <a:t>[−6,+12](5개 포함), [+40,+46],</a:t>
+                        <a:t>② 구간 A∈[+40, +46]</a:t>
                       </a:r>
                     </a:p>
                     <a:p>
@@ -3352,7 +3352,7 @@
                         <a:defRPr sz="1000"/>
                       </a:pPr>
                       <a:r>
-                        <a:t>−20, +22, −34</a:t>
+                        <a:t>③ 피크 −20  ④ 피크 +22</a:t>
                       </a:r>
                     </a:p>
                     <a:p>
@@ -3360,23 +3360,7 @@
                         <a:defRPr sz="1000"/>
                       </a:pPr>
                       <a:r>
-                        <a:t>※ 단 개수·B값·정확한 A로</a:t>
-                      </a:r>
-                    </a:p>
-                    <a:p>
-                      <a:pPr>
-                        <a:defRPr sz="1000"/>
-                      </a:pPr>
-                      <a:r>
-                        <a:t>완성하는 후반 단계는 미재현</a:t>
-                      </a:r>
-                    </a:p>
-                    <a:p>
-                      <a:pPr>
-                        <a:defRPr sz="1000"/>
-                      </a:pPr>
-                      <a:r>
-                        <a:t>→ 스핀 '목록'은 미산출</a:t>
+                        <a:t>⑤ 피크 −34 (후보 −32와 일치)</a:t>
                       </a:r>
                     </a:p>
                   </a:txBody>
@@ -3582,7 +3566,15 @@
                         <a:defRPr sz="1000" b="1"/>
                       </a:pPr>
                       <a:r>
-                        <a:t>신뢰 근거</a:t>
+                        <a:t>비고</a:t>
+                      </a:r>
+                    </a:p>
+                    <a:p>
+                      <a:pPr>
+                        <a:defRPr sz="1000"/>
+                      </a:pPr>
+                      <a:r>
+                        <a:t>(총평)</a:t>
                       </a:r>
                     </a:p>
                   </a:txBody>
@@ -3597,7 +3589,7 @@
                         <a:defRPr sz="1000" b="1"/>
                       </a:pPr>
                       <a:r>
-                        <a:t>눈 판독</a:t>
+                        <a:t>눈 판독의 대략 위치 앵커 —</a:t>
                       </a:r>
                     </a:p>
                     <a:p>
@@ -3605,7 +3597,15 @@
                         <a:defRPr sz="1000"/>
                       </a:pPr>
                       <a:r>
-                        <a:t>(대략 위치 앵커)</a:t>
+                        <a:t>7개 전부 우리 목록에서 재발견</a:t>
+                      </a:r>
+                    </a:p>
+                    <a:p>
+                      <a:pPr>
+                        <a:defRPr sz="1000"/>
+                      </a:pPr>
+                      <a:r>
+                        <a:t>A⊥는 과대추정 경향</a:t>
                       </a:r>
                     </a:p>
                   </a:txBody>
@@ -3620,7 +3620,7 @@
                         <a:defRPr sz="1000" b="1"/>
                       </a:pPr>
                       <a:r>
-                        <a:t>윈도우 확률 고원 —</a:t>
+                        <a:t>위치는 맞추나 목록은 미완성 —</a:t>
                       </a:r>
                     </a:p>
                     <a:p>
@@ -3628,7 +3628,7 @@
                         <a:defRPr sz="1000"/>
                       </a:pPr>
                       <a:r>
-                        <a:t>고원 내 개별 스핀 분해 불가</a:t>
+                        <a:t>구간·피크 수준까지만 출력,</a:t>
                       </a:r>
                     </a:p>
                     <a:p>
@@ -3636,7 +3636,7 @@
                         <a:defRPr sz="1000"/>
                       </a:pPr>
                       <a:r>
-                        <a:t>(예: 최강 스핀 +8이 p=0.95인데도</a:t>
+                        <a:t>개수·B값·정확한 A를 정하는</a:t>
                       </a:r>
                     </a:p>
                     <a:p>
@@ -3644,7 +3644,7 @@
                         <a:defRPr sz="1000"/>
                       </a:pPr>
                       <a:r>
-                        <a:t>피크 검출에서 누락됨)</a:t>
+                        <a:t>후반 회귀 단계는 재현 범위 밖</a:t>
                       </a:r>
                     </a:p>
                   </a:txBody>
@@ -3659,7 +3659,7 @@
                         <a:defRPr sz="950" b="1"/>
                       </a:pPr>
                       <a:r>
-                        <a:t>BIC k*=14 = RJMCMC 최빈 15</a:t>
+                        <a:t>개수(BIC, RJMCMC 사후분포와 정합)</a:t>
                       </a:r>
                     </a:p>
                     <a:p>
@@ -3667,7 +3667,7 @@
                         <a:defRPr sz="950"/>
                       </a:pPr>
                       <a:r>
-                        <a:t>CI 상호 비겹침 · 잔차 노이즈 바닥</a:t>
+                        <a:t>·B값·95% CI까지 완성한 유일한 목록</a:t>
                       </a:r>
                     </a:p>
                     <a:p>
@@ -3675,7 +3675,7 @@
                         <a:defRPr sz="950"/>
                       </a:pPr>
                       <a:r>
-                        <a:t>실데이터 RMSE 0.088/0.116/0.176</a:t>
+                        <a:t>3개 측정 동시 재현 RMSE 0.088–0.176</a:t>
                       </a:r>
                     </a:p>
                   </a:txBody>

</xml_diff>

<commit_message>
Summary deck: add dataset-overview and noise-modelling slides before the 50-spin validation
- new slide: Delft 50-spin public dataset overview (scale, conditions, scoring box, detectability vs noise floor)
- new slide: noise modelling — sigma estimated from raw NV1/NV2 data via successive differences (0.030-0.077), adopted sigma=0.06 justified as conservative worst-channel level
- scripts/make_dataset_noise_assets.py generates both figure assets from the raw xlsx

Co-Authored-By: Claude Fable 5 <noreply@anthropic.com>
</commit_message>
<xml_diff>
--- a/results/NV_C13_summary_3slides.pptx
+++ b/results/NV_C13_summary_3slides.pptx
@@ -12,6 +12,8 @@
     <p:sldId id="260" r:id="rId11"/>
     <p:sldId id="261" r:id="rId12"/>
     <p:sldId id="262" r:id="rId13"/>
+    <p:sldId id="263" r:id="rId14"/>
+    <p:sldId id="264" r:id="rId15"/>
   </p:sldIdLst>
   <p:sldSz cx="12191695" cy="6858000" type="screen4x3"/>
   <p:notesSz cx="6858000" cy="9144000"/>
@@ -5936,7 +5938,7 @@
               <a:defRPr sz="2600" b="1"/>
             </a:pPr>
             <a:r>
-              <a:t>요약 ②: 공개 실측 50-스핀 배스로 검증</a:t>
+              <a:t>공개 50-스핀 데이터셋 개요 (van de Stolpe 2024)</a:t>
             </a:r>
           </a:p>
           <a:p>
@@ -5944,7 +5946,7 @@
               <a:defRPr sz="1200"/>
             </a:pPr>
             <a:r>
-              <a:t>van de Stolpe 2024 (4TU 공개) — Jung 2021과 같은 NV 계보 · 정답을 아는 유일한 실제 스핀 환경</a:t>
+              <a:t>Delft 단일 NV 주변 ¹³C 핵스핀 네트워크 — 4TU.ResearchData 공개 · Jung 2021과 같은 NV 계보</a:t>
             </a:r>
           </a:p>
           <a:p>
@@ -5956,14 +5958,14 @@
               </a:defRPr>
             </a:pPr>
             <a:r>
-              <a:t>▶ 저온 트윈 21/27 회수(RMSE 0.074) · 상온 트윈 11/27·오탐 0 — 스핀 값은 학습에 미사용(순수 테스트)</a:t>
+              <a:t>▶ 50개 스핀의 (A∥, A⊥)가 전부 공개된, '정답을 아는' 유일한 실제 스핀 환경 — 다음 두 슬라이드 검증의 GT</a:t>
             </a:r>
           </a:p>
         </p:txBody>
       </p:sp>
       <p:pic>
         <p:nvPicPr>
-          <p:cNvPr id="3" name="Picture 2" descr="26_twin_validation.png"/>
+          <p:cNvPr id="3" name="Picture 2" descr="delft50_overview.png"/>
           <p:cNvPicPr>
             <a:picLocks noChangeAspect="1"/>
           </p:cNvPicPr>
@@ -5977,8 +5979,8 @@
         </p:blipFill>
         <p:spPr>
           <a:xfrm>
-            <a:off x="1097280" y="1325880"/>
-            <a:ext cx="9692640" cy="4984786"/>
+            <a:off x="685800" y="1371600"/>
+            <a:ext cx="10789920" cy="3082834"/>
           </a:xfrm>
           <a:prstGeom prst="rect">
             <a:avLst/>
@@ -5993,8 +5995,8 @@
         </p:nvSpPr>
         <p:spPr>
           <a:xfrm>
-            <a:off x="365760" y="6355080"/>
-            <a:ext cx="11430000" cy="457200"/>
+            <a:off x="365760" y="4617720"/>
+            <a:ext cx="11430000" cy="1920240"/>
           </a:xfrm>
           <a:prstGeom prst="rect">
             <a:avLst/>
@@ -6002,16 +6004,40 @@
           <a:noFill/>
         </p:spPr>
         <p:txBody>
-          <a:bodyPr wrap="none">
+          <a:bodyPr wrap="square">
             <a:spAutoFit/>
           </a:bodyPr>
           <a:lstStyle/>
           <a:p>
             <a:pPr>
-              <a:defRPr sz="1200"/>
-            </a:pPr>
-            <a:r>
-              <a:t>• 벤치마크 종합(F1): 제안 하이브리드 v2가 저온 0.84 / 상온 0.57 / 오차주입 0.61로 전 조건 1위 (2021 재현 0.38/0.37/0.35, 고전 DE 0.71/0.50/0.48, RJMCMC 0.84/0.56/0.52)</a:t>
+              <a:defRPr sz="1150"/>
+            </a:pPr>
+            <a:r>
+              <a:t>• 규모 — ¹³C 핵스핀 50개(+질소 1) · 각 스핀의 hyperfine (A∥, A⊥) 정밀값 공개: A∥ −48.5 ~ +213.2 kHz, A⊥ 0.2 ~ 59.2 kHz</a:t>
+            </a:r>
+          </a:p>
+          <a:p>
+            <a:pPr>
+              <a:defRPr sz="1150"/>
+            </a:pPr>
+            <a:r>
+              <a:t>• 측정 조건 — 저온(~4 K) · B = 403.553 G · 장시간 상관 센싱 시퀀스로 매핑 · 핵스핀-핵스핀 커플링 474쌍도 공개(중앙값 수 Hz → 우리 측정창 14~28 µs에서는 무시 가능)</a:t>
+            </a:r>
+          </a:p>
+          <a:p>
+            <a:pPr>
+              <a:defRPr sz="1150"/>
+            </a:pPr>
+            <a:r>
+              <a:t>• 채점 GT — 검출 대역 박스(|A∥| ≤ 60 kHz, A⊥ ≥ 5 kHz) 안 27개로 채점 · 박스 밖 23개는 dip이 약하거나(A⊥ &lt; 5 kHz) 대역 밖(최강 1개) — 원리적으로 우리 창에서 미검출</a:t>
+            </a:r>
+          </a:p>
+          <a:p>
+            <a:pPr>
+              <a:defRPr sz="1150"/>
+            </a:pPr>
+            <a:r>
+              <a:t>• 오른쪽 그림 — 같은 50개라도 측정 창에 따라 노이즈 바닥(2σ) 위 스핀 수가 다름: 저온 창이 상온 창보다 유리 → 트윈 검증의 회수율 차이(21/27 vs 11/27)의 구조적 원인</a:t>
             </a:r>
           </a:p>
         </p:txBody>
@@ -6060,6 +6086,309 @@
               <a:defRPr sz="2600" b="1"/>
             </a:pPr>
             <a:r>
+              <a:t>노이즈 모델링 — 트윈 합성 σ의 근거</a:t>
+            </a:r>
+          </a:p>
+          <a:p>
+            <a:pPr>
+              <a:defRPr sz="1200"/>
+            </a:pPr>
+            <a:r>
+              <a:t>노이즈 수준은 검증의 민감 변수 — 임의 가정이 아니라 NV1·NV2 실측 데이터에서 통계적으로 추정</a:t>
+            </a:r>
+          </a:p>
+          <a:p>
+            <a:pPr>
+              <a:defRPr sz="1400" b="1">
+                <a:solidFill>
+                  <a:srgbClr val="B45000"/>
+                </a:solidFill>
+              </a:defRPr>
+            </a:pPr>
+            <a:r>
+              <a:t>▶ 상온 트윈 σ=0.06은 실측 채널 σ̂(0.030~0.077)의 최악 수준을 취한 보수적 값 · 저온 트윈은 문헌 조건 σ=0.02</a:t>
+            </a:r>
+          </a:p>
+        </p:txBody>
+      </p:sp>
+      <p:sp>
+        <p:nvSpPr>
+          <p:cNvPr id="3" name="TextBox 2"/>
+          <p:cNvSpPr txBox="1"/>
+          <p:nvPr/>
+        </p:nvSpPr>
+        <p:spPr>
+          <a:xfrm>
+            <a:off x="365760" y="1371600"/>
+            <a:ext cx="11430000" cy="1828800"/>
+          </a:xfrm>
+          <a:prstGeom prst="rect">
+            <a:avLst/>
+          </a:prstGeom>
+          <a:noFill/>
+        </p:spPr>
+        <p:txBody>
+          <a:bodyPr wrap="square">
+            <a:spAutoFit/>
+          </a:bodyPr>
+          <a:lstStyle/>
+          <a:p>
+            <a:pPr>
+              <a:defRPr sz="1250"/>
+            </a:pPr>
+            <a:r>
+              <a:t>① 추정량 — 인접점 차분 dᵢ = yᵢ₊₁ − yᵢ 는 느리게 변하는 신호 성분을 상쇄시키고 노이즈만 남김 → σ̂ = std(d)/√2  (독립 가우시안 가정의 표준 추정)</a:t>
+            </a:r>
+          </a:p>
+          <a:p>
+            <a:pPr>
+              <a:defRPr sz="1250"/>
+            </a:pPr>
+            <a:r>
+              <a:t>② 실측 결과 — NV1 σ̂ = 0.030 / 0.047 / 0.065 (N=8/16/20) · NV2 σ̂ = 0.077 — dip 구간의 신호 혼입만큼 과대평가 쪽으로 치우침(= 보수적 상한)</a:t>
+            </a:r>
+          </a:p>
+          <a:p>
+            <a:pPr>
+              <a:defRPr sz="1250"/>
+            </a:pPr>
+            <a:r>
+              <a:t>③ 트윈 합성 — 상온 트윈 σ = 0.06(백색 가우시안, NV1 최악 채널 수준) · 저온 트윈 σ = 0.02(문헌 조건) · T2 포락선·콘트라스트도 실측 범위에서 랜덤</a:t>
+            </a:r>
+          </a:p>
+          <a:p>
+            <a:pPr>
+              <a:defRPr sz="1250"/>
+            </a:pPr>
+            <a:r>
+              <a:t>④ 과적합 방지 — 학습 데이터는 σ 고정이 아니라 [0.03, 0.12] 범위 무작위 → 특정 노이즈 수준에 특화된 검출기가 되는 것을 차단</a:t>
+            </a:r>
+          </a:p>
+        </p:txBody>
+      </p:sp>
+      <p:pic>
+        <p:nvPicPr>
+          <p:cNvPr id="4" name="Picture 3" descr="noise_model.png"/>
+          <p:cNvPicPr>
+            <a:picLocks noChangeAspect="1"/>
+          </p:cNvPicPr>
+          <p:nvPr/>
+        </p:nvPicPr>
+        <p:blipFill>
+          <a:blip r:embed="rId2"/>
+          <a:stretch>
+            <a:fillRect/>
+          </a:stretch>
+        </p:blipFill>
+        <p:spPr>
+          <a:xfrm>
+            <a:off x="320040" y="3520440"/>
+            <a:ext cx="11567160" cy="2313432"/>
+          </a:xfrm>
+          <a:prstGeom prst="rect">
+            <a:avLst/>
+          </a:prstGeom>
+        </p:spPr>
+      </p:pic>
+      <p:sp>
+        <p:nvSpPr>
+          <p:cNvPr id="5" name="TextBox 4"/>
+          <p:cNvSpPr txBox="1"/>
+          <p:nvPr/>
+        </p:nvSpPr>
+        <p:spPr>
+          <a:xfrm>
+            <a:off x="365760" y="6080760"/>
+            <a:ext cx="11430000" cy="548640"/>
+          </a:xfrm>
+          <a:prstGeom prst="rect">
+            <a:avLst/>
+          </a:prstGeom>
+          <a:noFill/>
+        </p:spPr>
+        <p:txBody>
+          <a:bodyPr wrap="square">
+            <a:spAutoFit/>
+          </a:bodyPr>
+          <a:lstStyle/>
+          <a:p>
+            <a:pPr>
+              <a:defRPr sz="1100"/>
+            </a:pPr>
+            <a:r>
+              <a:t>• 그림: NV1(N=8/16/20)·NV2(N=16) 원시 데이터 확대(τ 4–7 µs) — 이동중앙값(빨강) 주변 산포가 ±2σ̂ 밴드와 일치    • 맨 오른쪽: 채널별 σ̂ vs 채택값(0.06)·학습 범위(0.03–0.12)</a:t>
+            </a:r>
+          </a:p>
+        </p:txBody>
+      </p:sp>
+    </p:spTree>
+  </p:cSld>
+  <p:clrMapOvr>
+    <a:masterClrMapping/>
+  </p:clrMapOvr>
+</p:sld>
+</file>
+
+<file path=ppt/slides/slide6.xml><?xml version="1.0" encoding="utf-8"?>
+<p:sld xmlns:a="http://schemas.openxmlformats.org/drawingml/2006/main" xmlns:p="http://schemas.openxmlformats.org/presentationml/2006/main" xmlns:r="http://schemas.openxmlformats.org/officeDocument/2006/relationships">
+  <p:cSld>
+    <p:spTree>
+      <p:nvGrpSpPr>
+        <p:cNvPr id="1" name=""/>
+        <p:cNvGrpSpPr/>
+        <p:nvPr/>
+      </p:nvGrpSpPr>
+      <p:grpSpPr/>
+      <p:sp>
+        <p:nvSpPr>
+          <p:cNvPr id="2" name="TextBox 1"/>
+          <p:cNvSpPr txBox="1"/>
+          <p:nvPr/>
+        </p:nvSpPr>
+        <p:spPr>
+          <a:xfrm>
+            <a:off x="365760" y="109728"/>
+            <a:ext cx="11430000" cy="914400"/>
+          </a:xfrm>
+          <a:prstGeom prst="rect">
+            <a:avLst/>
+          </a:prstGeom>
+          <a:noFill/>
+        </p:spPr>
+        <p:txBody>
+          <a:bodyPr wrap="none">
+            <a:spAutoFit/>
+          </a:bodyPr>
+          <a:lstStyle/>
+          <a:p>
+            <a:pPr>
+              <a:defRPr sz="2600" b="1"/>
+            </a:pPr>
+            <a:r>
+              <a:t>요약 ②: 공개 실측 50-스핀 배스로 검증</a:t>
+            </a:r>
+          </a:p>
+          <a:p>
+            <a:pPr>
+              <a:defRPr sz="1200"/>
+            </a:pPr>
+            <a:r>
+              <a:t>van de Stolpe 2024 (4TU 공개) — Jung 2021과 같은 NV 계보 · 정답을 아는 유일한 실제 스핀 환경</a:t>
+            </a:r>
+          </a:p>
+          <a:p>
+            <a:pPr>
+              <a:defRPr sz="1400" b="1">
+                <a:solidFill>
+                  <a:srgbClr val="B45000"/>
+                </a:solidFill>
+              </a:defRPr>
+            </a:pPr>
+            <a:r>
+              <a:t>▶ 저온 트윈 21/27 회수(RMSE 0.074) · 상온 트윈 11/27·오탐 0 — 스핀 값은 학습에 미사용(순수 테스트)</a:t>
+            </a:r>
+          </a:p>
+        </p:txBody>
+      </p:sp>
+      <p:pic>
+        <p:nvPicPr>
+          <p:cNvPr id="3" name="Picture 2" descr="26_twin_validation.png"/>
+          <p:cNvPicPr>
+            <a:picLocks noChangeAspect="1"/>
+          </p:cNvPicPr>
+          <p:nvPr/>
+        </p:nvPicPr>
+        <p:blipFill>
+          <a:blip r:embed="rId2"/>
+          <a:stretch>
+            <a:fillRect/>
+          </a:stretch>
+        </p:blipFill>
+        <p:spPr>
+          <a:xfrm>
+            <a:off x="1097280" y="1325880"/>
+            <a:ext cx="9692640" cy="4984786"/>
+          </a:xfrm>
+          <a:prstGeom prst="rect">
+            <a:avLst/>
+          </a:prstGeom>
+        </p:spPr>
+      </p:pic>
+      <p:sp>
+        <p:nvSpPr>
+          <p:cNvPr id="4" name="TextBox 3"/>
+          <p:cNvSpPr txBox="1"/>
+          <p:nvPr/>
+        </p:nvSpPr>
+        <p:spPr>
+          <a:xfrm>
+            <a:off x="365760" y="6355080"/>
+            <a:ext cx="11430000" cy="457200"/>
+          </a:xfrm>
+          <a:prstGeom prst="rect">
+            <a:avLst/>
+          </a:prstGeom>
+          <a:noFill/>
+        </p:spPr>
+        <p:txBody>
+          <a:bodyPr wrap="none">
+            <a:spAutoFit/>
+          </a:bodyPr>
+          <a:lstStyle/>
+          <a:p>
+            <a:pPr>
+              <a:defRPr sz="1200"/>
+            </a:pPr>
+            <a:r>
+              <a:t>• 벤치마크 종합(F1): 제안 하이브리드 v2가 저온 0.84 / 상온 0.57 / 오차주입 0.61로 전 조건 1위 (2021 재현 0.38/0.37/0.35, 고전 DE 0.71/0.50/0.48, RJMCMC 0.84/0.56/0.52)</a:t>
+            </a:r>
+          </a:p>
+        </p:txBody>
+      </p:sp>
+    </p:spTree>
+  </p:cSld>
+  <p:clrMapOvr>
+    <a:masterClrMapping/>
+  </p:clrMapOvr>
+</p:sld>
+</file>
+
+<file path=ppt/slides/slide7.xml><?xml version="1.0" encoding="utf-8"?>
+<p:sld xmlns:a="http://schemas.openxmlformats.org/drawingml/2006/main" xmlns:p="http://schemas.openxmlformats.org/presentationml/2006/main" xmlns:r="http://schemas.openxmlformats.org/officeDocument/2006/relationships">
+  <p:cSld>
+    <p:spTree>
+      <p:nvGrpSpPr>
+        <p:cNvPr id="1" name=""/>
+        <p:cNvGrpSpPr/>
+        <p:nvPr/>
+      </p:nvGrpSpPr>
+      <p:grpSpPr/>
+      <p:sp>
+        <p:nvSpPr>
+          <p:cNvPr id="2" name="TextBox 1"/>
+          <p:cNvSpPr txBox="1"/>
+          <p:nvPr/>
+        </p:nvSpPr>
+        <p:spPr>
+          <a:xfrm>
+            <a:off x="365760" y="109728"/>
+            <a:ext cx="11430000" cy="914400"/>
+          </a:xfrm>
+          <a:prstGeom prst="rect">
+            <a:avLst/>
+          </a:prstGeom>
+          <a:noFill/>
+        </p:spPr>
+        <p:txBody>
+          <a:bodyPr wrap="none">
+            <a:spAutoFit/>
+          </a:bodyPr>
+          <a:lstStyle/>
+          <a:p>
+            <a:pPr>
+              <a:defRPr sz="2600" b="1"/>
+            </a:pPr>
+            <a:r>
               <a:t>요약 ③: 실제 CPMG 데이터 (NV1: N=8/16/20 · NV2: N=16)와 최종 피팅</a:t>
             </a:r>
           </a:p>
@@ -6172,7 +6501,7 @@
 </p:sld>
 </file>
 
-<file path=ppt/slides/slide6.xml><?xml version="1.0" encoding="utf-8"?>
+<file path=ppt/slides/slide8.xml><?xml version="1.0" encoding="utf-8"?>
 <p:sld xmlns:a="http://schemas.openxmlformats.org/drawingml/2006/main" xmlns:p="http://schemas.openxmlformats.org/presentationml/2006/main" xmlns:r="http://schemas.openxmlformats.org/officeDocument/2006/relationships">
   <p:cSld>
     <p:spTree>
@@ -7040,7 +7369,7 @@
 </p:sld>
 </file>
 
-<file path=ppt/slides/slide7.xml><?xml version="1.0" encoding="utf-8"?>
+<file path=ppt/slides/slide9.xml><?xml version="1.0" encoding="utf-8"?>
 <p:sld xmlns:a="http://schemas.openxmlformats.org/drawingml/2006/main" xmlns:p="http://schemas.openxmlformats.org/presentationml/2006/main" xmlns:r="http://schemas.openxmlformats.org/officeDocument/2006/relationships">
   <p:cSld>
     <p:spTree>

</xml_diff>